<commit_message>
docs: update presentation content for Investigacion Aumentada IA para la Ciencia
</commit_message>
<xml_diff>
--- a/Investigacion_Aumentada_IA_para_la_Ciencia.pptx
+++ b/Investigacion_Aumentada_IA_para_la_Ciencia.pptx
@@ -9808,7 +9808,7 @@
         <p:spPr>
           <a:xfrm>
             <a:off x="685800" y="1783080"/>
-            <a:ext cx="10607040" cy="3840480"/>
+            <a:ext cx="10607040" cy="1804725"/>
           </a:xfrm>
           <a:prstGeom prst="rect">
             <a:avLst/>
@@ -9830,22 +9830,121 @@
               </a:spcAft>
             </a:pPr>
             <a:r>
-              <a:rPr sz="1550" b="1" i="0">
+              <a:rPr sz="1550" b="1" i="0" dirty="0">
                 <a:solidFill>
                   <a:srgbClr val="0EA5E9"/>
                 </a:solidFill>
                 <a:latin typeface="Lato"/>
               </a:rPr>
-              <a:t>—  Editor de código  </a:t>
-            </a:r>
-            <a:r>
-              <a:rPr sz="1550" b="0" i="0">
-                <a:solidFill>
-                  <a:srgbClr val="475569"/>
-                </a:solidFill>
-                <a:latin typeface="Lato"/>
-              </a:rPr>
-              <a:t>idéntico a VS Code: árbol de archivos, pestañas y resaltado de sintaxis.</a:t>
+              <a:t>—  Editor de </a:t>
+            </a:r>
+            <a:r>
+              <a:rPr sz="1550" b="1" i="0" dirty="0" err="1">
+                <a:solidFill>
+                  <a:srgbClr val="0EA5E9"/>
+                </a:solidFill>
+                <a:latin typeface="Lato"/>
+              </a:rPr>
+              <a:t>código</a:t>
+            </a:r>
+            <a:r>
+              <a:rPr sz="1550" b="1" i="0" dirty="0">
+                <a:solidFill>
+                  <a:srgbClr val="0EA5E9"/>
+                </a:solidFill>
+                <a:latin typeface="Lato"/>
+              </a:rPr>
+              <a:t>  </a:t>
+            </a:r>
+            <a:r>
+              <a:rPr sz="1550" b="0" i="0" dirty="0" err="1">
+                <a:solidFill>
+                  <a:srgbClr val="475569"/>
+                </a:solidFill>
+                <a:latin typeface="Lato"/>
+              </a:rPr>
+              <a:t>idéntico</a:t>
+            </a:r>
+            <a:r>
+              <a:rPr sz="1550" b="0" i="0" dirty="0">
+                <a:solidFill>
+                  <a:srgbClr val="475569"/>
+                </a:solidFill>
+                <a:latin typeface="Lato"/>
+              </a:rPr>
+              <a:t> a VS Code: árbol de </a:t>
+            </a:r>
+            <a:r>
+              <a:rPr sz="1550" b="0" i="0" dirty="0" err="1">
+                <a:solidFill>
+                  <a:srgbClr val="475569"/>
+                </a:solidFill>
+                <a:latin typeface="Lato"/>
+              </a:rPr>
+              <a:t>archivos</a:t>
+            </a:r>
+            <a:r>
+              <a:rPr sz="1550" b="0" i="0" dirty="0">
+                <a:solidFill>
+                  <a:srgbClr val="475569"/>
+                </a:solidFill>
+                <a:latin typeface="Lato"/>
+              </a:rPr>
+              <a:t>, </a:t>
+            </a:r>
+            <a:r>
+              <a:rPr sz="1550" b="0" i="0" dirty="0" err="1">
+                <a:solidFill>
+                  <a:srgbClr val="475569"/>
+                </a:solidFill>
+                <a:latin typeface="Lato"/>
+              </a:rPr>
+              <a:t>pestañas</a:t>
+            </a:r>
+            <a:r>
+              <a:rPr sz="1550" b="0" i="0" dirty="0">
+                <a:solidFill>
+                  <a:srgbClr val="475569"/>
+                </a:solidFill>
+                <a:latin typeface="Lato"/>
+              </a:rPr>
+              <a:t> y </a:t>
+            </a:r>
+            <a:r>
+              <a:rPr sz="1550" b="0" i="0" dirty="0" err="1">
+                <a:solidFill>
+                  <a:srgbClr val="475569"/>
+                </a:solidFill>
+                <a:latin typeface="Lato"/>
+              </a:rPr>
+              <a:t>resaltado</a:t>
+            </a:r>
+            <a:r>
+              <a:rPr sz="1550" b="0" i="0" dirty="0">
+                <a:solidFill>
+                  <a:srgbClr val="475569"/>
+                </a:solidFill>
+                <a:latin typeface="Lato"/>
+              </a:rPr>
+              <a:t> de </a:t>
+            </a:r>
+            <a:r>
+              <a:rPr sz="1550" b="0" i="0" dirty="0" err="1">
+                <a:solidFill>
+                  <a:srgbClr val="475569"/>
+                </a:solidFill>
+                <a:latin typeface="Lato"/>
+              </a:rPr>
+              <a:t>sintaxis</a:t>
+            </a:r>
+            <a:r>
+              <a:rPr sz="1550" b="0" i="0" dirty="0">
+                <a:solidFill>
+                  <a:srgbClr val="475569"/>
+                </a:solidFill>
+                <a:latin typeface="Lato"/>
+              </a:rPr>
+              <a:t>.</a:t>
             </a:r>
           </a:p>
           <a:p>
@@ -9858,7 +9957,7 @@
               </a:spcAft>
             </a:pPr>
             <a:r>
-              <a:rPr sz="1550" b="1" i="0">
+              <a:rPr sz="1550" b="1" i="0" dirty="0">
                 <a:solidFill>
                   <a:srgbClr val="0EA5E9"/>
                 </a:solidFill>
@@ -9867,13 +9966,175 @@
               <a:t>—  Agent Manager  </a:t>
             </a:r>
             <a:r>
-              <a:rPr sz="1550" b="0" i="0">
-                <a:solidFill>
-                  <a:srgbClr val="475569"/>
-                </a:solidFill>
-                <a:latin typeface="Lato"/>
-              </a:rPr>
-              <a:t>panel donde defines la tarea, eliges el modelo (Gemini/Claude) y sigues el progreso del agente en tiempo real.</a:t>
+              <a:rPr sz="1550" b="0" i="0" dirty="0">
+                <a:solidFill>
+                  <a:srgbClr val="475569"/>
+                </a:solidFill>
+                <a:latin typeface="Lato"/>
+              </a:rPr>
+              <a:t>panel </a:t>
+            </a:r>
+            <a:r>
+              <a:rPr sz="1550" b="0" i="0" dirty="0" err="1">
+                <a:solidFill>
+                  <a:srgbClr val="475569"/>
+                </a:solidFill>
+                <a:latin typeface="Lato"/>
+              </a:rPr>
+              <a:t>donde</a:t>
+            </a:r>
+            <a:r>
+              <a:rPr sz="1550" b="0" i="0" dirty="0">
+                <a:solidFill>
+                  <a:srgbClr val="475569"/>
+                </a:solidFill>
+                <a:latin typeface="Lato"/>
+              </a:rPr>
+              <a:t> defines la </a:t>
+            </a:r>
+            <a:r>
+              <a:rPr sz="1550" b="0" i="0" dirty="0" err="1">
+                <a:solidFill>
+                  <a:srgbClr val="475569"/>
+                </a:solidFill>
+                <a:latin typeface="Lato"/>
+              </a:rPr>
+              <a:t>tarea</a:t>
+            </a:r>
+            <a:r>
+              <a:rPr sz="1550" b="0" i="0" dirty="0">
+                <a:solidFill>
+                  <a:srgbClr val="475569"/>
+                </a:solidFill>
+                <a:latin typeface="Lato"/>
+              </a:rPr>
+              <a:t>, </a:t>
+            </a:r>
+            <a:r>
+              <a:rPr sz="1550" b="0" i="0" dirty="0" err="1">
+                <a:solidFill>
+                  <a:srgbClr val="475569"/>
+                </a:solidFill>
+                <a:latin typeface="Lato"/>
+              </a:rPr>
+              <a:t>eliges</a:t>
+            </a:r>
+            <a:r>
+              <a:rPr sz="1550" b="0" i="0" dirty="0">
+                <a:solidFill>
+                  <a:srgbClr val="475569"/>
+                </a:solidFill>
+                <a:latin typeface="Lato"/>
+              </a:rPr>
+              <a:t> el </a:t>
+            </a:r>
+            <a:r>
+              <a:rPr sz="1550" b="0" i="0" dirty="0" err="1">
+                <a:solidFill>
+                  <a:srgbClr val="475569"/>
+                </a:solidFill>
+                <a:latin typeface="Lato"/>
+              </a:rPr>
+              <a:t>modelo</a:t>
+            </a:r>
+            <a:r>
+              <a:rPr sz="1550" b="0" i="0" dirty="0">
+                <a:solidFill>
+                  <a:srgbClr val="475569"/>
+                </a:solidFill>
+                <a:latin typeface="Lato"/>
+              </a:rPr>
+              <a:t> (Gemini/Claude) y </a:t>
+            </a:r>
+            <a:r>
+              <a:rPr sz="1550" b="0" i="0" dirty="0" err="1">
+                <a:solidFill>
+                  <a:srgbClr val="475569"/>
+                </a:solidFill>
+                <a:latin typeface="Lato"/>
+              </a:rPr>
+              <a:t>sigues</a:t>
+            </a:r>
+            <a:r>
+              <a:rPr sz="1550" b="0" i="0" dirty="0">
+                <a:solidFill>
+                  <a:srgbClr val="475569"/>
+                </a:solidFill>
+                <a:latin typeface="Lato"/>
+              </a:rPr>
+              <a:t> el </a:t>
+            </a:r>
+            <a:r>
+              <a:rPr sz="1550" b="0" i="0" dirty="0" err="1">
+                <a:solidFill>
+                  <a:srgbClr val="475569"/>
+                </a:solidFill>
+                <a:latin typeface="Lato"/>
+              </a:rPr>
+              <a:t>progreso</a:t>
+            </a:r>
+            <a:r>
+              <a:rPr sz="1550" b="0" i="0" dirty="0">
+                <a:solidFill>
+                  <a:srgbClr val="475569"/>
+                </a:solidFill>
+                <a:latin typeface="Lato"/>
+              </a:rPr>
+              <a:t> del </a:t>
+            </a:r>
+            <a:r>
+              <a:rPr sz="1550" b="0" i="0" dirty="0" err="1">
+                <a:solidFill>
+                  <a:srgbClr val="475569"/>
+                </a:solidFill>
+                <a:latin typeface="Lato"/>
+              </a:rPr>
+              <a:t>agente</a:t>
+            </a:r>
+            <a:r>
+              <a:rPr sz="1550" b="0" i="0" dirty="0">
+                <a:solidFill>
+                  <a:srgbClr val="475569"/>
+                </a:solidFill>
+                <a:latin typeface="Lato"/>
+              </a:rPr>
+              <a:t> </a:t>
+            </a:r>
+            <a:r>
+              <a:rPr sz="1550" b="0" i="0" dirty="0" err="1">
+                <a:solidFill>
+                  <a:srgbClr val="475569"/>
+                </a:solidFill>
+                <a:latin typeface="Lato"/>
+              </a:rPr>
+              <a:t>en</a:t>
+            </a:r>
+            <a:r>
+              <a:rPr sz="1550" b="0" i="0" dirty="0">
+                <a:solidFill>
+                  <a:srgbClr val="475569"/>
+                </a:solidFill>
+                <a:latin typeface="Lato"/>
+              </a:rPr>
+              <a:t> </a:t>
+            </a:r>
+            <a:r>
+              <a:rPr sz="1550" b="0" i="0" dirty="0" err="1">
+                <a:solidFill>
+                  <a:srgbClr val="475569"/>
+                </a:solidFill>
+                <a:latin typeface="Lato"/>
+              </a:rPr>
+              <a:t>tiempo</a:t>
+            </a:r>
+            <a:r>
+              <a:rPr sz="1550" b="0" i="0" dirty="0">
+                <a:solidFill>
+                  <a:srgbClr val="475569"/>
+                </a:solidFill>
+                <a:latin typeface="Lato"/>
+              </a:rPr>
+              <a:t> real.</a:t>
             </a:r>
           </a:p>
           <a:p>
@@ -9886,22 +10147,121 @@
               </a:spcAft>
             </a:pPr>
             <a:r>
-              <a:rPr sz="1550" b="1" i="0">
+              <a:rPr sz="1550" b="1" i="0" dirty="0">
                 <a:solidFill>
                   <a:srgbClr val="0EA5E9"/>
                 </a:solidFill>
                 <a:latin typeface="Lato"/>
               </a:rPr>
-              <a:t>—  Terminal y Source Control  </a:t>
-            </a:r>
-            <a:r>
-              <a:rPr sz="1550" b="0" i="0">
-                <a:solidFill>
-                  <a:srgbClr val="475569"/>
-                </a:solidFill>
-                <a:latin typeface="Lato"/>
-              </a:rPr>
-              <a:t>consola integrada y panel de Git para revisar cambios antes de confirmarlos.</a:t>
+              <a:t>—  Terminal y Control</a:t>
+            </a:r>
+            <a:r>
+              <a:rPr lang="es-CO" sz="1550" b="1" i="0" dirty="0">
+                <a:solidFill>
+                  <a:srgbClr val="0EA5E9"/>
+                </a:solidFill>
+                <a:latin typeface="Lato"/>
+              </a:rPr>
+              <a:t>  de fuentes</a:t>
+            </a:r>
+            <a:r>
+              <a:rPr sz="1550" b="1" i="0" dirty="0">
+                <a:solidFill>
+                  <a:srgbClr val="0EA5E9"/>
+                </a:solidFill>
+                <a:latin typeface="Lato"/>
+              </a:rPr>
+              <a:t>  </a:t>
+            </a:r>
+            <a:r>
+              <a:rPr sz="1550" b="0" i="0" dirty="0" err="1">
+                <a:solidFill>
+                  <a:srgbClr val="475569"/>
+                </a:solidFill>
+                <a:latin typeface="Lato"/>
+              </a:rPr>
+              <a:t>consola</a:t>
+            </a:r>
+            <a:r>
+              <a:rPr sz="1550" b="0" i="0" dirty="0">
+                <a:solidFill>
+                  <a:srgbClr val="475569"/>
+                </a:solidFill>
+                <a:latin typeface="Lato"/>
+              </a:rPr>
+              <a:t> </a:t>
+            </a:r>
+            <a:r>
+              <a:rPr sz="1550" b="0" i="0" dirty="0" err="1">
+                <a:solidFill>
+                  <a:srgbClr val="475569"/>
+                </a:solidFill>
+                <a:latin typeface="Lato"/>
+              </a:rPr>
+              <a:t>integrada</a:t>
+            </a:r>
+            <a:r>
+              <a:rPr sz="1550" b="0" i="0" dirty="0">
+                <a:solidFill>
+                  <a:srgbClr val="475569"/>
+                </a:solidFill>
+                <a:latin typeface="Lato"/>
+              </a:rPr>
+              <a:t> y panel de Git para </a:t>
+            </a:r>
+            <a:r>
+              <a:rPr sz="1550" b="0" i="0" dirty="0" err="1">
+                <a:solidFill>
+                  <a:srgbClr val="475569"/>
+                </a:solidFill>
+                <a:latin typeface="Lato"/>
+              </a:rPr>
+              <a:t>revisar</a:t>
+            </a:r>
+            <a:r>
+              <a:rPr sz="1550" b="0" i="0" dirty="0">
+                <a:solidFill>
+                  <a:srgbClr val="475569"/>
+                </a:solidFill>
+                <a:latin typeface="Lato"/>
+              </a:rPr>
+              <a:t> </a:t>
+            </a:r>
+            <a:r>
+              <a:rPr sz="1550" b="0" i="0" dirty="0" err="1">
+                <a:solidFill>
+                  <a:srgbClr val="475569"/>
+                </a:solidFill>
+                <a:latin typeface="Lato"/>
+              </a:rPr>
+              <a:t>cambios</a:t>
+            </a:r>
+            <a:r>
+              <a:rPr sz="1550" b="0" i="0" dirty="0">
+                <a:solidFill>
+                  <a:srgbClr val="475569"/>
+                </a:solidFill>
+                <a:latin typeface="Lato"/>
+              </a:rPr>
+              <a:t> antes de </a:t>
+            </a:r>
+            <a:r>
+              <a:rPr sz="1550" b="0" i="0" dirty="0" err="1">
+                <a:solidFill>
+                  <a:srgbClr val="475569"/>
+                </a:solidFill>
+                <a:latin typeface="Lato"/>
+              </a:rPr>
+              <a:t>confirmarlos</a:t>
+            </a:r>
+            <a:r>
+              <a:rPr sz="1550" b="0" i="0" dirty="0">
+                <a:solidFill>
+                  <a:srgbClr val="475569"/>
+                </a:solidFill>
+                <a:latin typeface="Lato"/>
+              </a:rPr>
+              <a:t>.</a:t>
             </a:r>
           </a:p>
           <a:p>
@@ -9914,22 +10274,157 @@
               </a:spcAft>
             </a:pPr>
             <a:r>
-              <a:rPr sz="1550" b="1" i="0">
+              <a:rPr sz="1550" b="1" i="0" dirty="0">
                 <a:solidFill>
                   <a:srgbClr val="0EA5E9"/>
                 </a:solidFill>
                 <a:latin typeface="Lato"/>
               </a:rPr>
-              <a:t>—  Artifacts / vista previa  </a:t>
-            </a:r>
-            <a:r>
-              <a:rPr sz="1550" b="0" i="0">
-                <a:solidFill>
-                  <a:srgbClr val="475569"/>
-                </a:solidFill>
-                <a:latin typeface="Lato"/>
-              </a:rPr>
-              <a:t>muestra gráficos, notebooks o páginas generadas por el agente sin salir del entorno.</a:t>
+              <a:t>—  vista previa  </a:t>
+            </a:r>
+            <a:r>
+              <a:rPr sz="1550" b="0" i="0" dirty="0" err="1">
+                <a:solidFill>
+                  <a:srgbClr val="475569"/>
+                </a:solidFill>
+                <a:latin typeface="Lato"/>
+              </a:rPr>
+              <a:t>muestra</a:t>
+            </a:r>
+            <a:r>
+              <a:rPr sz="1550" b="0" i="0" dirty="0">
+                <a:solidFill>
+                  <a:srgbClr val="475569"/>
+                </a:solidFill>
+                <a:latin typeface="Lato"/>
+              </a:rPr>
+              <a:t> </a:t>
+            </a:r>
+            <a:r>
+              <a:rPr sz="1550" b="0" i="0" dirty="0" err="1">
+                <a:solidFill>
+                  <a:srgbClr val="475569"/>
+                </a:solidFill>
+                <a:latin typeface="Lato"/>
+              </a:rPr>
+              <a:t>gráficos</a:t>
+            </a:r>
+            <a:r>
+              <a:rPr sz="1550" b="0" i="0" dirty="0">
+                <a:solidFill>
+                  <a:srgbClr val="475569"/>
+                </a:solidFill>
+                <a:latin typeface="Lato"/>
+              </a:rPr>
+              <a:t>, notebooks o </a:t>
+            </a:r>
+            <a:r>
+              <a:rPr sz="1550" b="0" i="0" dirty="0" err="1">
+                <a:solidFill>
+                  <a:srgbClr val="475569"/>
+                </a:solidFill>
+                <a:latin typeface="Lato"/>
+              </a:rPr>
+              <a:t>páginas</a:t>
+            </a:r>
+            <a:r>
+              <a:rPr sz="1550" b="0" i="0" dirty="0">
+                <a:solidFill>
+                  <a:srgbClr val="475569"/>
+                </a:solidFill>
+                <a:latin typeface="Lato"/>
+              </a:rPr>
+              <a:t> </a:t>
+            </a:r>
+            <a:r>
+              <a:rPr sz="1550" b="0" i="0" dirty="0" err="1">
+                <a:solidFill>
+                  <a:srgbClr val="475569"/>
+                </a:solidFill>
+                <a:latin typeface="Lato"/>
+              </a:rPr>
+              <a:t>generadas</a:t>
+            </a:r>
+            <a:r>
+              <a:rPr sz="1550" b="0" i="0" dirty="0">
+                <a:solidFill>
+                  <a:srgbClr val="475569"/>
+                </a:solidFill>
+                <a:latin typeface="Lato"/>
+              </a:rPr>
+              <a:t> </a:t>
+            </a:r>
+            <a:r>
+              <a:rPr sz="1550" b="0" i="0" dirty="0" err="1">
+                <a:solidFill>
+                  <a:srgbClr val="475569"/>
+                </a:solidFill>
+                <a:latin typeface="Lato"/>
+              </a:rPr>
+              <a:t>por</a:t>
+            </a:r>
+            <a:r>
+              <a:rPr sz="1550" b="0" i="0" dirty="0">
+                <a:solidFill>
+                  <a:srgbClr val="475569"/>
+                </a:solidFill>
+                <a:latin typeface="Lato"/>
+              </a:rPr>
+              <a:t> el </a:t>
+            </a:r>
+            <a:r>
+              <a:rPr sz="1550" b="0" i="0" dirty="0" err="1">
+                <a:solidFill>
+                  <a:srgbClr val="475569"/>
+                </a:solidFill>
+                <a:latin typeface="Lato"/>
+              </a:rPr>
+              <a:t>agente</a:t>
+            </a:r>
+            <a:r>
+              <a:rPr sz="1550" b="0" i="0" dirty="0">
+                <a:solidFill>
+                  <a:srgbClr val="475569"/>
+                </a:solidFill>
+                <a:latin typeface="Lato"/>
+              </a:rPr>
+              <a:t> sin </a:t>
+            </a:r>
+            <a:r>
+              <a:rPr sz="1550" b="0" i="0" dirty="0" err="1">
+                <a:solidFill>
+                  <a:srgbClr val="475569"/>
+                </a:solidFill>
+                <a:latin typeface="Lato"/>
+              </a:rPr>
+              <a:t>salir</a:t>
+            </a:r>
+            <a:r>
+              <a:rPr sz="1550" b="0" i="0" dirty="0">
+                <a:solidFill>
+                  <a:srgbClr val="475569"/>
+                </a:solidFill>
+                <a:latin typeface="Lato"/>
+              </a:rPr>
+              <a:t> del </a:t>
+            </a:r>
+            <a:r>
+              <a:rPr sz="1550" b="0" i="0" dirty="0" err="1">
+                <a:solidFill>
+                  <a:srgbClr val="475569"/>
+                </a:solidFill>
+                <a:latin typeface="Lato"/>
+              </a:rPr>
+              <a:t>entorno</a:t>
+            </a:r>
+            <a:r>
+              <a:rPr sz="1550" b="0" i="0" dirty="0">
+                <a:solidFill>
+                  <a:srgbClr val="475569"/>
+                </a:solidFill>
+                <a:latin typeface="Lato"/>
+              </a:rPr>
+              <a:t>.</a:t>
             </a:r>
           </a:p>
         </p:txBody>
@@ -10012,6 +10507,36 @@
           </a:p>
         </p:txBody>
       </p:sp>
+      <p:pic>
+        <p:nvPicPr>
+          <p:cNvPr id="9" name="Imagen 8">
+            <a:extLst>
+              <a:ext uri="{FF2B5EF4-FFF2-40B4-BE49-F238E27FC236}">
+                <a16:creationId xmlns:a16="http://schemas.microsoft.com/office/drawing/2014/main" id="{9A9F2136-1C5A-5408-FC01-824DA8EFA89A}"/>
+              </a:ext>
+            </a:extLst>
+          </p:cNvPr>
+          <p:cNvPicPr>
+            <a:picLocks noChangeAspect="1"/>
+          </p:cNvPicPr>
+          <p:nvPr/>
+        </p:nvPicPr>
+        <p:blipFill>
+          <a:blip r:embed="rId2"/>
+          <a:stretch>
+            <a:fillRect/>
+          </a:stretch>
+        </p:blipFill>
+        <p:spPr>
+          <a:xfrm>
+            <a:off x="3536829" y="3768428"/>
+            <a:ext cx="4591549" cy="2586652"/>
+          </a:xfrm>
+          <a:prstGeom prst="rect">
+            <a:avLst/>
+          </a:prstGeom>
+        </p:spPr>
+      </p:pic>
     </p:spTree>
   </p:cSld>
   <p:clrMapOvr>
@@ -12081,7 +12606,7 @@
         <p:spPr>
           <a:xfrm>
             <a:off x="1252728" y="2093976"/>
-            <a:ext cx="10250424" cy="710946"/>
+            <a:ext cx="10250424" cy="188898"/>
           </a:xfrm>
           <a:prstGeom prst="rect">
             <a:avLst/>
@@ -12100,13 +12625,103 @@
               </a:lnSpc>
             </a:pPr>
             <a:r>
-              <a:rPr sz="1180" b="0" i="0">
-                <a:solidFill>
-                  <a:srgbClr val="475569"/>
-                </a:solidFill>
-                <a:latin typeface="Lato"/>
-              </a:rPr>
-              <a:t>gemini.google.com, con tu cuenta de Google — ideal para explorar ideas y redactar texto.</a:t>
+              <a:rPr sz="1180" b="0" i="0" dirty="0">
+                <a:solidFill>
+                  <a:srgbClr val="475569"/>
+                </a:solidFill>
+                <a:latin typeface="Lato"/>
+              </a:rPr>
+              <a:t>gemini.google.com, con </a:t>
+            </a:r>
+            <a:r>
+              <a:rPr sz="1180" b="0" i="0" dirty="0" err="1">
+                <a:solidFill>
+                  <a:srgbClr val="475569"/>
+                </a:solidFill>
+                <a:latin typeface="Lato"/>
+              </a:rPr>
+              <a:t>tu</a:t>
+            </a:r>
+            <a:r>
+              <a:rPr sz="1180" b="0" i="0" dirty="0">
+                <a:solidFill>
+                  <a:srgbClr val="475569"/>
+                </a:solidFill>
+                <a:latin typeface="Lato"/>
+              </a:rPr>
+              <a:t> </a:t>
+            </a:r>
+            <a:r>
+              <a:rPr sz="1180" b="0" i="0" dirty="0" err="1">
+                <a:solidFill>
+                  <a:srgbClr val="475569"/>
+                </a:solidFill>
+                <a:latin typeface="Lato"/>
+              </a:rPr>
+              <a:t>cuenta</a:t>
+            </a:r>
+            <a:r>
+              <a:rPr sz="1180" b="0" i="0" dirty="0">
+                <a:solidFill>
+                  <a:srgbClr val="475569"/>
+                </a:solidFill>
+                <a:latin typeface="Lato"/>
+              </a:rPr>
+              <a:t> de Google — ideal para </a:t>
+            </a:r>
+            <a:r>
+              <a:rPr sz="1180" b="0" i="0" dirty="0" err="1">
+                <a:solidFill>
+                  <a:srgbClr val="C00000"/>
+                </a:solidFill>
+                <a:latin typeface="Lato"/>
+              </a:rPr>
+              <a:t>explorar</a:t>
+            </a:r>
+            <a:r>
+              <a:rPr sz="1180" b="0" i="0" dirty="0">
+                <a:solidFill>
+                  <a:srgbClr val="C00000"/>
+                </a:solidFill>
+                <a:latin typeface="Lato"/>
+              </a:rPr>
+              <a:t> ideas y </a:t>
+            </a:r>
+            <a:r>
+              <a:rPr sz="1180" b="0" i="0" dirty="0" err="1">
+                <a:solidFill>
+                  <a:srgbClr val="C00000"/>
+                </a:solidFill>
+                <a:latin typeface="Lato"/>
+              </a:rPr>
+              <a:t>redactar</a:t>
+            </a:r>
+            <a:r>
+              <a:rPr sz="1180" b="0" i="0" dirty="0">
+                <a:solidFill>
+                  <a:srgbClr val="C00000"/>
+                </a:solidFill>
+                <a:latin typeface="Lato"/>
+              </a:rPr>
+              <a:t> </a:t>
+            </a:r>
+            <a:r>
+              <a:rPr sz="1180" b="0" i="0" dirty="0" err="1">
+                <a:solidFill>
+                  <a:srgbClr val="C00000"/>
+                </a:solidFill>
+                <a:latin typeface="Lato"/>
+              </a:rPr>
+              <a:t>texto</a:t>
+            </a:r>
+            <a:r>
+              <a:rPr sz="1180" b="0" i="0" dirty="0">
+                <a:solidFill>
+                  <a:srgbClr val="475569"/>
+                </a:solidFill>
+                <a:latin typeface="Lato"/>
+              </a:rPr>
+              <a:t>.</a:t>
             </a:r>
           </a:p>
         </p:txBody>
@@ -12248,7 +12863,7 @@
         <p:spPr>
           <a:xfrm>
             <a:off x="1252728" y="3134106"/>
-            <a:ext cx="10250424" cy="710946"/>
+            <a:ext cx="10250424" cy="188898"/>
           </a:xfrm>
           <a:prstGeom prst="rect">
             <a:avLst/>
@@ -12267,13 +12882,112 @@
               </a:lnSpc>
             </a:pPr>
             <a:r>
-              <a:rPr sz="1180" b="0" i="0">
-                <a:solidFill>
-                  <a:srgbClr val="475569"/>
-                </a:solidFill>
-                <a:latin typeface="Lato"/>
-              </a:rPr>
-              <a:t>aistudio.google.com permite generar una API key para integraciones de desarrollo.</a:t>
+              <a:rPr sz="1180" b="0" i="0" dirty="0">
+                <a:solidFill>
+                  <a:srgbClr val="475569"/>
+                </a:solidFill>
+                <a:latin typeface="Lato"/>
+              </a:rPr>
+              <a:t>aistudio.google.com </a:t>
+            </a:r>
+            <a:r>
+              <a:rPr sz="1180" b="0" i="0" dirty="0" err="1">
+                <a:solidFill>
+                  <a:srgbClr val="475569"/>
+                </a:solidFill>
+                <a:latin typeface="Lato"/>
+              </a:rPr>
+              <a:t>permite</a:t>
+            </a:r>
+            <a:r>
+              <a:rPr sz="1180" b="0" i="0" dirty="0">
+                <a:solidFill>
+                  <a:srgbClr val="475569"/>
+                </a:solidFill>
+                <a:latin typeface="Lato"/>
+              </a:rPr>
+              <a:t> </a:t>
+            </a:r>
+            <a:r>
+              <a:rPr sz="1180" b="0" i="0" dirty="0" err="1">
+                <a:solidFill>
+                  <a:srgbClr val="475569"/>
+                </a:solidFill>
+                <a:latin typeface="Lato"/>
+              </a:rPr>
+              <a:t>generar</a:t>
+            </a:r>
+            <a:r>
+              <a:rPr sz="1180" b="0" i="0" dirty="0">
+                <a:solidFill>
+                  <a:srgbClr val="475569"/>
+                </a:solidFill>
+                <a:latin typeface="Lato"/>
+              </a:rPr>
+              <a:t> </a:t>
+            </a:r>
+            <a:r>
+              <a:rPr sz="1180" b="0" i="0" dirty="0" err="1">
+                <a:solidFill>
+                  <a:srgbClr val="C00000"/>
+                </a:solidFill>
+                <a:latin typeface="Lato"/>
+              </a:rPr>
+              <a:t>una</a:t>
+            </a:r>
+            <a:r>
+              <a:rPr sz="1180" b="0" i="0" dirty="0">
+                <a:solidFill>
+                  <a:srgbClr val="C00000"/>
+                </a:solidFill>
+                <a:latin typeface="Lato"/>
+              </a:rPr>
+              <a:t> API key </a:t>
+            </a:r>
+            <a:r>
+              <a:rPr sz="1180" b="0" i="0" dirty="0">
+                <a:solidFill>
+                  <a:srgbClr val="475569"/>
+                </a:solidFill>
+                <a:latin typeface="Lato"/>
+              </a:rPr>
+              <a:t>para </a:t>
+            </a:r>
+            <a:r>
+              <a:rPr sz="1180" b="0" i="0" dirty="0" err="1">
+                <a:solidFill>
+                  <a:srgbClr val="475569"/>
+                </a:solidFill>
+                <a:latin typeface="Lato"/>
+              </a:rPr>
+              <a:t>integraciones</a:t>
+            </a:r>
+            <a:r>
+              <a:rPr sz="1180" b="0" i="0" dirty="0">
+                <a:solidFill>
+                  <a:srgbClr val="475569"/>
+                </a:solidFill>
+                <a:latin typeface="Lato"/>
+              </a:rPr>
+              <a:t> de </a:t>
+            </a:r>
+            <a:r>
+              <a:rPr sz="1180" b="0" i="0" dirty="0" err="1">
+                <a:solidFill>
+                  <a:srgbClr val="475569"/>
+                </a:solidFill>
+                <a:latin typeface="Lato"/>
+              </a:rPr>
+              <a:t>desarrollo</a:t>
+            </a:r>
+            <a:r>
+              <a:rPr sz="1180" b="0" i="0" dirty="0">
+                <a:solidFill>
+                  <a:srgbClr val="475569"/>
+                </a:solidFill>
+                <a:latin typeface="Lato"/>
+              </a:rPr>
+              <a:t>.</a:t>
             </a:r>
           </a:p>
         </p:txBody>
@@ -12415,7 +13129,7 @@
         <p:spPr>
           <a:xfrm>
             <a:off x="1252728" y="4174236"/>
-            <a:ext cx="10250424" cy="710946"/>
+            <a:ext cx="10250424" cy="188898"/>
           </a:xfrm>
           <a:prstGeom prst="rect">
             <a:avLst/>
@@ -12434,13 +13148,103 @@
               </a:lnSpc>
             </a:pPr>
             <a:r>
-              <a:rPr sz="1180" b="0" i="0">
-                <a:solidFill>
-                  <a:srgbClr val="475569"/>
-                </a:solidFill>
-                <a:latin typeface="Lato"/>
-              </a:rPr>
-              <a:t>Gemini viene disponible por defecto en el selector de modelos del Agent Manager.</a:t>
+              <a:rPr sz="1180" b="0" i="0" dirty="0">
+                <a:solidFill>
+                  <a:srgbClr val="C00000"/>
+                </a:solidFill>
+                <a:latin typeface="Lato"/>
+              </a:rPr>
+              <a:t>Gemini </a:t>
+            </a:r>
+            <a:r>
+              <a:rPr sz="1180" b="0" i="0" dirty="0" err="1">
+                <a:solidFill>
+                  <a:srgbClr val="C00000"/>
+                </a:solidFill>
+                <a:latin typeface="Lato"/>
+              </a:rPr>
+              <a:t>viene</a:t>
+            </a:r>
+            <a:r>
+              <a:rPr sz="1180" b="0" i="0" dirty="0">
+                <a:solidFill>
+                  <a:srgbClr val="C00000"/>
+                </a:solidFill>
+                <a:latin typeface="Lato"/>
+              </a:rPr>
+              <a:t> disponible </a:t>
+            </a:r>
+            <a:r>
+              <a:rPr sz="1180" b="0" i="0" dirty="0" err="1">
+                <a:solidFill>
+                  <a:srgbClr val="475569"/>
+                </a:solidFill>
+                <a:latin typeface="Lato"/>
+              </a:rPr>
+              <a:t>por</a:t>
+            </a:r>
+            <a:r>
+              <a:rPr sz="1180" b="0" i="0" dirty="0">
+                <a:solidFill>
+                  <a:srgbClr val="475569"/>
+                </a:solidFill>
+                <a:latin typeface="Lato"/>
+              </a:rPr>
+              <a:t> </a:t>
+            </a:r>
+            <a:r>
+              <a:rPr sz="1180" b="0" i="0" dirty="0" err="1">
+                <a:solidFill>
+                  <a:srgbClr val="475569"/>
+                </a:solidFill>
+                <a:latin typeface="Lato"/>
+              </a:rPr>
+              <a:t>defecto</a:t>
+            </a:r>
+            <a:r>
+              <a:rPr sz="1180" b="0" i="0" dirty="0">
+                <a:solidFill>
+                  <a:srgbClr val="475569"/>
+                </a:solidFill>
+                <a:latin typeface="Lato"/>
+              </a:rPr>
+              <a:t> </a:t>
+            </a:r>
+            <a:r>
+              <a:rPr sz="1180" b="0" i="0" dirty="0" err="1">
+                <a:solidFill>
+                  <a:srgbClr val="475569"/>
+                </a:solidFill>
+                <a:latin typeface="Lato"/>
+              </a:rPr>
+              <a:t>en</a:t>
+            </a:r>
+            <a:r>
+              <a:rPr sz="1180" b="0" i="0" dirty="0">
+                <a:solidFill>
+                  <a:srgbClr val="475569"/>
+                </a:solidFill>
+                <a:latin typeface="Lato"/>
+              </a:rPr>
+              <a:t> el selector de </a:t>
+            </a:r>
+            <a:r>
+              <a:rPr sz="1180" b="0" i="0" dirty="0" err="1">
+                <a:solidFill>
+                  <a:srgbClr val="475569"/>
+                </a:solidFill>
+                <a:latin typeface="Lato"/>
+              </a:rPr>
+              <a:t>modelos</a:t>
+            </a:r>
+            <a:r>
+              <a:rPr sz="1180" b="0" i="0" dirty="0">
+                <a:solidFill>
+                  <a:srgbClr val="475569"/>
+                </a:solidFill>
+                <a:latin typeface="Lato"/>
+              </a:rPr>
+              <a:t> del Agent Manager.</a:t>
             </a:r>
           </a:p>
         </p:txBody>
@@ -12938,7 +13742,7 @@
         <p:spPr>
           <a:xfrm>
             <a:off x="1252728" y="2093976"/>
-            <a:ext cx="10250424" cy="710946"/>
+            <a:ext cx="10250424" cy="188898"/>
           </a:xfrm>
           <a:prstGeom prst="rect">
             <a:avLst/>
@@ -12957,13 +13761,76 @@
               </a:lnSpc>
             </a:pPr>
             <a:r>
-              <a:rPr sz="1180" b="0" i="0">
-                <a:solidFill>
-                  <a:srgbClr val="475569"/>
-                </a:solidFill>
-                <a:latin typeface="Lato"/>
-              </a:rPr>
-              <a:t>claude.ai, con planes Free y Pro — ideal para razonamiento profundo y redacción científica.</a:t>
+              <a:rPr sz="1180" b="0" i="0" dirty="0">
+                <a:solidFill>
+                  <a:srgbClr val="475569"/>
+                </a:solidFill>
+                <a:latin typeface="Lato"/>
+              </a:rPr>
+              <a:t>claude.ai, con planes Free y Pro — ideal </a:t>
+            </a:r>
+            <a:r>
+              <a:rPr sz="1180" b="0" i="0" dirty="0">
+                <a:solidFill>
+                  <a:srgbClr val="C00000"/>
+                </a:solidFill>
+                <a:latin typeface="Lato"/>
+              </a:rPr>
+              <a:t>para </a:t>
+            </a:r>
+            <a:r>
+              <a:rPr sz="1180" b="0" i="0" dirty="0" err="1">
+                <a:solidFill>
+                  <a:srgbClr val="C00000"/>
+                </a:solidFill>
+                <a:latin typeface="Lato"/>
+              </a:rPr>
+              <a:t>razonamiento</a:t>
+            </a:r>
+            <a:r>
+              <a:rPr sz="1180" b="0" i="0" dirty="0">
+                <a:solidFill>
+                  <a:srgbClr val="C00000"/>
+                </a:solidFill>
+                <a:latin typeface="Lato"/>
+              </a:rPr>
+              <a:t> profundo y </a:t>
+            </a:r>
+            <a:r>
+              <a:rPr sz="1180" b="0" i="0" dirty="0" err="1">
+                <a:solidFill>
+                  <a:srgbClr val="C00000"/>
+                </a:solidFill>
+                <a:latin typeface="Lato"/>
+              </a:rPr>
+              <a:t>redacción</a:t>
+            </a:r>
+            <a:r>
+              <a:rPr sz="1180" b="0" i="0" dirty="0">
+                <a:solidFill>
+                  <a:srgbClr val="C00000"/>
+                </a:solidFill>
+                <a:latin typeface="Lato"/>
+              </a:rPr>
+              <a:t> </a:t>
+            </a:r>
+            <a:r>
+              <a:rPr sz="1180" b="0" i="0" dirty="0" err="1">
+                <a:solidFill>
+                  <a:srgbClr val="C00000"/>
+                </a:solidFill>
+                <a:latin typeface="Lato"/>
+              </a:rPr>
+              <a:t>científica</a:t>
+            </a:r>
+            <a:r>
+              <a:rPr sz="1180" b="0" i="0" dirty="0">
+                <a:solidFill>
+                  <a:srgbClr val="475569"/>
+                </a:solidFill>
+                <a:latin typeface="Lato"/>
+              </a:rPr>
+              <a:t>.</a:t>
             </a:r>
           </a:p>
         </p:txBody>
@@ -13105,7 +13972,7 @@
         <p:spPr>
           <a:xfrm>
             <a:off x="1252728" y="3134106"/>
-            <a:ext cx="10250424" cy="710946"/>
+            <a:ext cx="10250424" cy="188898"/>
           </a:xfrm>
           <a:prstGeom prst="rect">
             <a:avLst/>
@@ -13124,13 +13991,121 @@
               </a:lnSpc>
             </a:pPr>
             <a:r>
-              <a:rPr sz="1180" b="0" i="0">
-                <a:solidFill>
-                  <a:srgbClr val="475569"/>
-                </a:solidFill>
-                <a:latin typeface="Lato"/>
-              </a:rPr>
-              <a:t>se instala con “npm install -g @anthropic-ai/claude-code” (requiere Node.js) y corre en la terminal del proyecto.</a:t>
+              <a:rPr sz="1180" b="0" i="0" dirty="0">
+                <a:solidFill>
+                  <a:srgbClr val="475569"/>
+                </a:solidFill>
+                <a:latin typeface="Lato"/>
+              </a:rPr>
+              <a:t>se </a:t>
+            </a:r>
+            <a:r>
+              <a:rPr sz="1180" b="0" i="0" dirty="0" err="1">
+                <a:solidFill>
+                  <a:srgbClr val="475569"/>
+                </a:solidFill>
+                <a:latin typeface="Lato"/>
+              </a:rPr>
+              <a:t>instala</a:t>
+            </a:r>
+            <a:r>
+              <a:rPr sz="1180" b="0" i="0" dirty="0">
+                <a:solidFill>
+                  <a:srgbClr val="475569"/>
+                </a:solidFill>
+                <a:latin typeface="Lato"/>
+              </a:rPr>
+              <a:t> con “</a:t>
+            </a:r>
+            <a:r>
+              <a:rPr sz="1180" b="0" i="0" dirty="0" err="1">
+                <a:solidFill>
+                  <a:srgbClr val="475569"/>
+                </a:solidFill>
+                <a:latin typeface="Lato"/>
+              </a:rPr>
+              <a:t>npm</a:t>
+            </a:r>
+            <a:r>
+              <a:rPr sz="1180" b="0" i="0" dirty="0">
+                <a:solidFill>
+                  <a:srgbClr val="475569"/>
+                </a:solidFill>
+                <a:latin typeface="Lato"/>
+              </a:rPr>
+              <a:t> install -g @anthropic-ai/claude-code” (</a:t>
+            </a:r>
+            <a:r>
+              <a:rPr sz="1180" b="0" i="0" dirty="0" err="1">
+                <a:solidFill>
+                  <a:srgbClr val="475569"/>
+                </a:solidFill>
+                <a:latin typeface="Lato"/>
+              </a:rPr>
+              <a:t>requiere</a:t>
+            </a:r>
+            <a:r>
+              <a:rPr sz="1180" b="0" i="0" dirty="0">
+                <a:solidFill>
+                  <a:srgbClr val="475569"/>
+                </a:solidFill>
+                <a:latin typeface="Lato"/>
+              </a:rPr>
+              <a:t> Node.js) y </a:t>
+            </a:r>
+            <a:r>
+              <a:rPr sz="1180" b="0" i="0" dirty="0" err="1">
+                <a:solidFill>
+                  <a:srgbClr val="C00000"/>
+                </a:solidFill>
+                <a:latin typeface="Lato"/>
+              </a:rPr>
+              <a:t>corre</a:t>
+            </a:r>
+            <a:r>
+              <a:rPr sz="1180" b="0" i="0" dirty="0">
+                <a:solidFill>
+                  <a:srgbClr val="C00000"/>
+                </a:solidFill>
+                <a:latin typeface="Lato"/>
+              </a:rPr>
+              <a:t> </a:t>
+            </a:r>
+            <a:r>
+              <a:rPr sz="1180" b="0" i="0" dirty="0" err="1">
+                <a:solidFill>
+                  <a:srgbClr val="C00000"/>
+                </a:solidFill>
+                <a:latin typeface="Lato"/>
+              </a:rPr>
+              <a:t>en</a:t>
+            </a:r>
+            <a:r>
+              <a:rPr sz="1180" b="0" i="0" dirty="0">
+                <a:solidFill>
+                  <a:srgbClr val="C00000"/>
+                </a:solidFill>
+                <a:latin typeface="Lato"/>
+              </a:rPr>
+              <a:t> la terminal del </a:t>
+            </a:r>
+            <a:r>
+              <a:rPr sz="1180" b="0" i="0" dirty="0" err="1">
+                <a:solidFill>
+                  <a:srgbClr val="C00000"/>
+                </a:solidFill>
+                <a:latin typeface="Lato"/>
+              </a:rPr>
+              <a:t>proyecto</a:t>
+            </a:r>
+            <a:r>
+              <a:rPr sz="1180" b="0" i="0" dirty="0">
+                <a:solidFill>
+                  <a:srgbClr val="475569"/>
+                </a:solidFill>
+                <a:latin typeface="Lato"/>
+              </a:rPr>
+              <a:t>.</a:t>
             </a:r>
           </a:p>
         </p:txBody>
@@ -13272,7 +14247,7 @@
         <p:spPr>
           <a:xfrm>
             <a:off x="1252728" y="4174236"/>
-            <a:ext cx="10250424" cy="710946"/>
+            <a:ext cx="10250424" cy="188898"/>
           </a:xfrm>
           <a:prstGeom prst="rect">
             <a:avLst/>
@@ -13291,13 +14266,139 @@
               </a:lnSpc>
             </a:pPr>
             <a:r>
-              <a:rPr sz="1180" b="0" i="0">
-                <a:solidFill>
-                  <a:srgbClr val="475569"/>
-                </a:solidFill>
-                <a:latin typeface="Lato"/>
-              </a:rPr>
-              <a:t>console.anthropic.com permite generar una API key para integrarlo en extensiones o agentes.</a:t>
+              <a:rPr sz="1180" b="0" i="0" dirty="0">
+                <a:solidFill>
+                  <a:srgbClr val="475569"/>
+                </a:solidFill>
+                <a:latin typeface="Lato"/>
+              </a:rPr>
+              <a:t>console.anthropic.com </a:t>
+            </a:r>
+            <a:r>
+              <a:rPr sz="1180" b="0" i="0" dirty="0" err="1">
+                <a:solidFill>
+                  <a:srgbClr val="475569"/>
+                </a:solidFill>
+                <a:latin typeface="Lato"/>
+              </a:rPr>
+              <a:t>permite</a:t>
+            </a:r>
+            <a:r>
+              <a:rPr sz="1180" b="0" i="0" dirty="0">
+                <a:solidFill>
+                  <a:srgbClr val="475569"/>
+                </a:solidFill>
+                <a:latin typeface="Lato"/>
+              </a:rPr>
+              <a:t> </a:t>
+            </a:r>
+            <a:r>
+              <a:rPr sz="1180" b="0" i="0" dirty="0" err="1">
+                <a:solidFill>
+                  <a:srgbClr val="475569"/>
+                </a:solidFill>
+                <a:latin typeface="Lato"/>
+              </a:rPr>
+              <a:t>generar</a:t>
+            </a:r>
+            <a:r>
+              <a:rPr sz="1180" b="0" i="0" dirty="0">
+                <a:solidFill>
+                  <a:srgbClr val="475569"/>
+                </a:solidFill>
+                <a:latin typeface="Lato"/>
+              </a:rPr>
+              <a:t> </a:t>
+            </a:r>
+            <a:r>
+              <a:rPr sz="1180" b="0" i="0" dirty="0" err="1">
+                <a:solidFill>
+                  <a:srgbClr val="C00000"/>
+                </a:solidFill>
+                <a:latin typeface="Lato"/>
+              </a:rPr>
+              <a:t>una</a:t>
+            </a:r>
+            <a:r>
+              <a:rPr sz="1180" b="0" i="0" dirty="0">
+                <a:solidFill>
+                  <a:srgbClr val="C00000"/>
+                </a:solidFill>
+                <a:latin typeface="Lato"/>
+              </a:rPr>
+              <a:t> API key para </a:t>
+            </a:r>
+            <a:r>
+              <a:rPr sz="1180" b="0" i="0" dirty="0" err="1">
+                <a:solidFill>
+                  <a:srgbClr val="C00000"/>
+                </a:solidFill>
+                <a:latin typeface="Lato"/>
+              </a:rPr>
+              <a:t>integrarlo</a:t>
+            </a:r>
+            <a:r>
+              <a:rPr sz="1180" b="0" i="0" dirty="0">
+                <a:solidFill>
+                  <a:srgbClr val="C00000"/>
+                </a:solidFill>
+                <a:latin typeface="Lato"/>
+              </a:rPr>
+              <a:t> </a:t>
+            </a:r>
+            <a:r>
+              <a:rPr sz="1180" b="0" i="0" dirty="0" err="1">
+                <a:solidFill>
+                  <a:srgbClr val="C00000"/>
+                </a:solidFill>
+                <a:latin typeface="Lato"/>
+              </a:rPr>
+              <a:t>en</a:t>
+            </a:r>
+            <a:r>
+              <a:rPr sz="1180" b="0" i="0" dirty="0">
+                <a:solidFill>
+                  <a:srgbClr val="C00000"/>
+                </a:solidFill>
+                <a:latin typeface="Lato"/>
+              </a:rPr>
+              <a:t> </a:t>
+            </a:r>
+            <a:r>
+              <a:rPr sz="1180" b="0" i="0" dirty="0" err="1">
+                <a:solidFill>
+                  <a:srgbClr val="C00000"/>
+                </a:solidFill>
+                <a:latin typeface="Lato"/>
+              </a:rPr>
+              <a:t>extensiones</a:t>
+            </a:r>
+            <a:r>
+              <a:rPr sz="1180" b="0" i="0" dirty="0">
+                <a:solidFill>
+                  <a:srgbClr val="C00000"/>
+                </a:solidFill>
+                <a:latin typeface="Lato"/>
+              </a:rPr>
+              <a:t> o </a:t>
+            </a:r>
+            <a:r>
+              <a:rPr sz="1180" b="0" i="0" dirty="0" err="1">
+                <a:solidFill>
+                  <a:srgbClr val="C00000"/>
+                </a:solidFill>
+                <a:latin typeface="Lato"/>
+              </a:rPr>
+              <a:t>agentes</a:t>
+            </a:r>
+            <a:r>
+              <a:rPr sz="1180" b="0" i="0" dirty="0">
+                <a:solidFill>
+                  <a:srgbClr val="475569"/>
+                </a:solidFill>
+                <a:latin typeface="Lato"/>
+              </a:rPr>
+              <a:t>.</a:t>
             </a:r>
           </a:p>
         </p:txBody>
@@ -25114,8 +26215,8 @@
         </p:nvSpPr>
         <p:spPr>
           <a:xfrm>
-            <a:off x="685800" y="1783080"/>
-            <a:ext cx="10607040" cy="502920"/>
+            <a:off x="685800" y="2050496"/>
+            <a:ext cx="10607040" cy="239617"/>
           </a:xfrm>
           <a:prstGeom prst="rect">
             <a:avLst/>
@@ -25134,13 +26235,157 @@
               </a:lnSpc>
             </a:pPr>
             <a:r>
-              <a:rPr sz="1450" b="0" i="1">
-                <a:solidFill>
-                  <a:srgbClr val="475569"/>
-                </a:solidFill>
-                <a:latin typeface="Lato"/>
-              </a:rPr>
-              <a:t>No buscamos delegar el criterio científico: buscamos expandir la capacidad del equipo para:</a:t>
+              <a:rPr sz="1450" b="0" i="1" dirty="0">
+                <a:solidFill>
+                  <a:srgbClr val="475569"/>
+                </a:solidFill>
+                <a:latin typeface="Lato"/>
+              </a:rPr>
+              <a:t>No </a:t>
+            </a:r>
+            <a:r>
+              <a:rPr sz="1450" b="0" i="1" dirty="0" err="1">
+                <a:solidFill>
+                  <a:srgbClr val="475569"/>
+                </a:solidFill>
+                <a:latin typeface="Lato"/>
+              </a:rPr>
+              <a:t>buscamos</a:t>
+            </a:r>
+            <a:r>
+              <a:rPr sz="1450" b="0" i="1" dirty="0">
+                <a:solidFill>
+                  <a:srgbClr val="475569"/>
+                </a:solidFill>
+                <a:latin typeface="Lato"/>
+              </a:rPr>
+              <a:t> </a:t>
+            </a:r>
+            <a:r>
+              <a:rPr sz="1450" b="1" i="1" dirty="0" err="1">
+                <a:solidFill>
+                  <a:srgbClr val="C00000"/>
+                </a:solidFill>
+                <a:latin typeface="Lato"/>
+              </a:rPr>
+              <a:t>delegar</a:t>
+            </a:r>
+            <a:r>
+              <a:rPr sz="1450" b="1" i="1" dirty="0">
+                <a:solidFill>
+                  <a:srgbClr val="C00000"/>
+                </a:solidFill>
+                <a:latin typeface="Lato"/>
+              </a:rPr>
+              <a:t> el </a:t>
+            </a:r>
+            <a:r>
+              <a:rPr sz="1450" b="1" i="1" dirty="0" err="1">
+                <a:solidFill>
+                  <a:srgbClr val="C00000"/>
+                </a:solidFill>
+                <a:latin typeface="Lato"/>
+              </a:rPr>
+              <a:t>criterio</a:t>
+            </a:r>
+            <a:r>
+              <a:rPr sz="1450" b="1" i="1" dirty="0">
+                <a:solidFill>
+                  <a:srgbClr val="C00000"/>
+                </a:solidFill>
+                <a:latin typeface="Lato"/>
+              </a:rPr>
+              <a:t> </a:t>
+            </a:r>
+            <a:r>
+              <a:rPr sz="1450" b="1" i="1" dirty="0" err="1">
+                <a:solidFill>
+                  <a:srgbClr val="C00000"/>
+                </a:solidFill>
+                <a:latin typeface="Lato"/>
+              </a:rPr>
+              <a:t>científico</a:t>
+            </a:r>
+            <a:r>
+              <a:rPr sz="1450" b="0" i="1" dirty="0">
+                <a:solidFill>
+                  <a:srgbClr val="475569"/>
+                </a:solidFill>
+                <a:latin typeface="Lato"/>
+              </a:rPr>
+              <a:t>: </a:t>
+            </a:r>
+            <a:r>
+              <a:rPr sz="1450" b="0" i="1" dirty="0" err="1">
+                <a:solidFill>
+                  <a:srgbClr val="475569"/>
+                </a:solidFill>
+                <a:latin typeface="Lato"/>
+              </a:rPr>
+              <a:t>buscamos</a:t>
+            </a:r>
+            <a:r>
+              <a:rPr sz="1450" b="0" i="1" dirty="0">
+                <a:solidFill>
+                  <a:srgbClr val="475569"/>
+                </a:solidFill>
+                <a:latin typeface="Lato"/>
+              </a:rPr>
+              <a:t> </a:t>
+            </a:r>
+            <a:r>
+              <a:rPr sz="1450" b="0" i="1" dirty="0" err="1">
+                <a:solidFill>
+                  <a:srgbClr val="475569"/>
+                </a:solidFill>
+                <a:latin typeface="Lato"/>
+              </a:rPr>
+              <a:t>expandir</a:t>
+            </a:r>
+            <a:r>
+              <a:rPr sz="1450" b="0" i="1" dirty="0">
+                <a:solidFill>
+                  <a:srgbClr val="475569"/>
+                </a:solidFill>
+                <a:latin typeface="Lato"/>
+              </a:rPr>
+              <a:t> la </a:t>
+            </a:r>
+            <a:r>
+              <a:rPr sz="1450" b="0" i="1" dirty="0" err="1">
+                <a:solidFill>
+                  <a:srgbClr val="475569"/>
+                </a:solidFill>
+                <a:latin typeface="Lato"/>
+              </a:rPr>
+              <a:t>capacidad</a:t>
+            </a:r>
+            <a:r>
+              <a:rPr sz="1450" b="0" i="1" dirty="0">
+                <a:solidFill>
+                  <a:srgbClr val="475569"/>
+                </a:solidFill>
+                <a:latin typeface="Lato"/>
+              </a:rPr>
+              <a:t> del </a:t>
+            </a:r>
+            <a:r>
+              <a:rPr sz="1450" b="0" i="1" dirty="0" err="1">
+                <a:solidFill>
+                  <a:srgbClr val="475569"/>
+                </a:solidFill>
+                <a:latin typeface="Lato"/>
+              </a:rPr>
+              <a:t>equipo</a:t>
+            </a:r>
+            <a:r>
+              <a:rPr sz="1450" b="0" i="1" dirty="0">
+                <a:solidFill>
+                  <a:srgbClr val="475569"/>
+                </a:solidFill>
+                <a:latin typeface="Lato"/>
+              </a:rPr>
+              <a:t> para:</a:t>
             </a:r>
           </a:p>
         </p:txBody>
@@ -25153,7 +26398,7 @@
         </p:nvSpPr>
         <p:spPr>
           <a:xfrm>
-            <a:off x="685800" y="2350008"/>
+            <a:off x="685800" y="2617424"/>
             <a:ext cx="10607040" cy="3840480"/>
           </a:xfrm>
           <a:prstGeom prst="rect">
@@ -25176,22 +26421,193 @@
               </a:spcAft>
             </a:pPr>
             <a:r>
-              <a:rPr sz="1550" b="1" i="0">
+              <a:rPr sz="1550" b="1" i="0" dirty="0">
                 <a:solidFill>
                   <a:srgbClr val="0EA5E9"/>
                 </a:solidFill>
                 <a:latin typeface="Lato"/>
               </a:rPr>
-              <a:t>—  Procesar volumen  </a:t>
-            </a:r>
-            <a:r>
-              <a:rPr sz="1550" b="0" i="0">
-                <a:solidFill>
-                  <a:srgbClr val="475569"/>
-                </a:solidFill>
-                <a:latin typeface="Lato"/>
-              </a:rPr>
-              <a:t>grandes series de datos, literatura y código en minutos en vez de días.</a:t>
+              <a:t>—  </a:t>
+            </a:r>
+            <a:r>
+              <a:rPr sz="1550" b="1" i="0" dirty="0" err="1">
+                <a:solidFill>
+                  <a:srgbClr val="0EA5E9"/>
+                </a:solidFill>
+                <a:latin typeface="Lato"/>
+              </a:rPr>
+              <a:t>Procesar</a:t>
+            </a:r>
+            <a:r>
+              <a:rPr sz="1550" b="1" i="0" dirty="0">
+                <a:solidFill>
+                  <a:srgbClr val="0EA5E9"/>
+                </a:solidFill>
+                <a:latin typeface="Lato"/>
+              </a:rPr>
+              <a:t> </a:t>
+            </a:r>
+            <a:r>
+              <a:rPr sz="1550" b="1" i="0" dirty="0" err="1">
+                <a:solidFill>
+                  <a:srgbClr val="0EA5E9"/>
+                </a:solidFill>
+                <a:latin typeface="Lato"/>
+              </a:rPr>
+              <a:t>volumen</a:t>
+            </a:r>
+            <a:r>
+              <a:rPr sz="1550" b="1" i="0" dirty="0">
+                <a:solidFill>
+                  <a:srgbClr val="0EA5E9"/>
+                </a:solidFill>
+                <a:latin typeface="Lato"/>
+              </a:rPr>
+              <a:t>  </a:t>
+            </a:r>
+            <a:r>
+              <a:rPr sz="1550" b="0" i="0" dirty="0" err="1">
+                <a:solidFill>
+                  <a:srgbClr val="475569"/>
+                </a:solidFill>
+                <a:latin typeface="Lato"/>
+              </a:rPr>
+              <a:t>grandes</a:t>
+            </a:r>
+            <a:r>
+              <a:rPr sz="1550" b="0" i="0" dirty="0">
+                <a:solidFill>
+                  <a:srgbClr val="475569"/>
+                </a:solidFill>
+                <a:latin typeface="Lato"/>
+              </a:rPr>
+              <a:t> series de </a:t>
+            </a:r>
+            <a:r>
+              <a:rPr sz="1550" b="0" i="0" dirty="0" err="1">
+                <a:solidFill>
+                  <a:srgbClr val="475569"/>
+                </a:solidFill>
+                <a:latin typeface="Lato"/>
+              </a:rPr>
+              <a:t>datos</a:t>
+            </a:r>
+            <a:r>
+              <a:rPr sz="1550" b="0" i="0" dirty="0">
+                <a:solidFill>
+                  <a:srgbClr val="475569"/>
+                </a:solidFill>
+                <a:latin typeface="Lato"/>
+              </a:rPr>
+              <a:t>, </a:t>
+            </a:r>
+            <a:r>
+              <a:rPr sz="1550" b="0" i="0" dirty="0" err="1">
+                <a:solidFill>
+                  <a:srgbClr val="475569"/>
+                </a:solidFill>
+                <a:latin typeface="Lato"/>
+              </a:rPr>
+              <a:t>literatura</a:t>
+            </a:r>
+            <a:r>
+              <a:rPr sz="1550" b="0" i="0" dirty="0">
+                <a:solidFill>
+                  <a:srgbClr val="475569"/>
+                </a:solidFill>
+                <a:latin typeface="Lato"/>
+              </a:rPr>
+              <a:t> y </a:t>
+            </a:r>
+            <a:r>
+              <a:rPr sz="1550" b="0" i="0" dirty="0" err="1">
+                <a:solidFill>
+                  <a:srgbClr val="475569"/>
+                </a:solidFill>
+                <a:latin typeface="Lato"/>
+              </a:rPr>
+              <a:t>código</a:t>
+            </a:r>
+            <a:r>
+              <a:rPr sz="1550" b="0" i="0" dirty="0">
+                <a:solidFill>
+                  <a:srgbClr val="475569"/>
+                </a:solidFill>
+                <a:latin typeface="Lato"/>
+              </a:rPr>
+              <a:t> </a:t>
+            </a:r>
+            <a:r>
+              <a:rPr sz="1550" b="0" i="0" dirty="0" err="1">
+                <a:solidFill>
+                  <a:srgbClr val="475569"/>
+                </a:solidFill>
+                <a:latin typeface="Lato"/>
+              </a:rPr>
+              <a:t>en</a:t>
+            </a:r>
+            <a:r>
+              <a:rPr sz="1550" b="0" i="0" dirty="0">
+                <a:solidFill>
+                  <a:srgbClr val="475569"/>
+                </a:solidFill>
+                <a:latin typeface="Lato"/>
+              </a:rPr>
+              <a:t> </a:t>
+            </a:r>
+            <a:r>
+              <a:rPr sz="1550" b="0" i="0" dirty="0" err="1">
+                <a:solidFill>
+                  <a:srgbClr val="475569"/>
+                </a:solidFill>
+                <a:latin typeface="Lato"/>
+              </a:rPr>
+              <a:t>minutos</a:t>
+            </a:r>
+            <a:r>
+              <a:rPr sz="1550" b="0" i="0" dirty="0">
+                <a:solidFill>
+                  <a:srgbClr val="475569"/>
+                </a:solidFill>
+                <a:latin typeface="Lato"/>
+              </a:rPr>
+              <a:t> </a:t>
+            </a:r>
+            <a:r>
+              <a:rPr sz="1550" b="0" i="0" dirty="0" err="1">
+                <a:solidFill>
+                  <a:srgbClr val="475569"/>
+                </a:solidFill>
+                <a:latin typeface="Lato"/>
+              </a:rPr>
+              <a:t>en</a:t>
+            </a:r>
+            <a:r>
+              <a:rPr sz="1550" b="0" i="0" dirty="0">
+                <a:solidFill>
+                  <a:srgbClr val="475569"/>
+                </a:solidFill>
+                <a:latin typeface="Lato"/>
+              </a:rPr>
+              <a:t> </a:t>
+            </a:r>
+            <a:r>
+              <a:rPr sz="1550" b="0" i="0" dirty="0" err="1">
+                <a:solidFill>
+                  <a:srgbClr val="475569"/>
+                </a:solidFill>
+                <a:latin typeface="Lato"/>
+              </a:rPr>
+              <a:t>vez</a:t>
+            </a:r>
+            <a:r>
+              <a:rPr sz="1550" b="0" i="0" dirty="0">
+                <a:solidFill>
+                  <a:srgbClr val="475569"/>
+                </a:solidFill>
+                <a:latin typeface="Lato"/>
+              </a:rPr>
+              <a:t> de días.</a:t>
             </a:r>
           </a:p>
           <a:p>
@@ -25204,22 +26620,193 @@
               </a:spcAft>
             </a:pPr>
             <a:r>
-              <a:rPr sz="1550" b="1" i="0">
+              <a:rPr sz="1550" b="1" i="0" dirty="0">
                 <a:solidFill>
                   <a:srgbClr val="0EA5E9"/>
                 </a:solidFill>
                 <a:latin typeface="Lato"/>
               </a:rPr>
-              <a:t>—  Traducir ideas a código  </a:t>
-            </a:r>
-            <a:r>
-              <a:rPr sz="1550" b="0" i="0">
-                <a:solidFill>
-                  <a:srgbClr val="475569"/>
-                </a:solidFill>
-                <a:latin typeface="Lato"/>
-              </a:rPr>
-              <a:t>convertir un modelo teórico o una ecuación en un script ejecutable y probado.</a:t>
+              <a:t>—  </a:t>
+            </a:r>
+            <a:r>
+              <a:rPr sz="1550" b="1" i="0" dirty="0" err="1">
+                <a:solidFill>
+                  <a:srgbClr val="0EA5E9"/>
+                </a:solidFill>
+                <a:latin typeface="Lato"/>
+              </a:rPr>
+              <a:t>Traducir</a:t>
+            </a:r>
+            <a:r>
+              <a:rPr sz="1550" b="1" i="0" dirty="0">
+                <a:solidFill>
+                  <a:srgbClr val="0EA5E9"/>
+                </a:solidFill>
+                <a:latin typeface="Lato"/>
+              </a:rPr>
+              <a:t> ideas a </a:t>
+            </a:r>
+            <a:r>
+              <a:rPr sz="1550" b="1" i="0" dirty="0" err="1">
+                <a:solidFill>
+                  <a:srgbClr val="0EA5E9"/>
+                </a:solidFill>
+                <a:latin typeface="Lato"/>
+              </a:rPr>
+              <a:t>código</a:t>
+            </a:r>
+            <a:r>
+              <a:rPr sz="1550" b="1" i="0" dirty="0">
+                <a:solidFill>
+                  <a:srgbClr val="0EA5E9"/>
+                </a:solidFill>
+                <a:latin typeface="Lato"/>
+              </a:rPr>
+              <a:t>  </a:t>
+            </a:r>
+            <a:r>
+              <a:rPr sz="1550" b="0" i="0" dirty="0" err="1">
+                <a:solidFill>
+                  <a:srgbClr val="475569"/>
+                </a:solidFill>
+                <a:latin typeface="Lato"/>
+              </a:rPr>
+              <a:t>convertir</a:t>
+            </a:r>
+            <a:r>
+              <a:rPr sz="1550" b="0" i="0" dirty="0">
+                <a:solidFill>
+                  <a:srgbClr val="475569"/>
+                </a:solidFill>
+                <a:latin typeface="Lato"/>
+              </a:rPr>
+              <a:t> un </a:t>
+            </a:r>
+            <a:r>
+              <a:rPr sz="1550" b="0" i="0" dirty="0" err="1">
+                <a:solidFill>
+                  <a:srgbClr val="475569"/>
+                </a:solidFill>
+                <a:latin typeface="Lato"/>
+              </a:rPr>
+              <a:t>modelo</a:t>
+            </a:r>
+            <a:r>
+              <a:rPr sz="1550" b="0" i="0" dirty="0">
+                <a:solidFill>
+                  <a:srgbClr val="475569"/>
+                </a:solidFill>
+                <a:latin typeface="Lato"/>
+              </a:rPr>
+              <a:t> </a:t>
+            </a:r>
+            <a:r>
+              <a:rPr sz="1550" b="0" i="0" dirty="0" err="1">
+                <a:solidFill>
+                  <a:srgbClr val="475569"/>
+                </a:solidFill>
+                <a:latin typeface="Lato"/>
+              </a:rPr>
+              <a:t>teórico</a:t>
+            </a:r>
+            <a:r>
+              <a:rPr sz="1550" b="0" i="0" dirty="0">
+                <a:solidFill>
+                  <a:srgbClr val="475569"/>
+                </a:solidFill>
+                <a:latin typeface="Lato"/>
+              </a:rPr>
+              <a:t> o </a:t>
+            </a:r>
+            <a:r>
+              <a:rPr sz="1550" b="0" i="0" dirty="0" err="1">
+                <a:solidFill>
+                  <a:srgbClr val="475569"/>
+                </a:solidFill>
+                <a:latin typeface="Lato"/>
+              </a:rPr>
+              <a:t>una</a:t>
+            </a:r>
+            <a:r>
+              <a:rPr sz="1550" b="0" i="0" dirty="0">
+                <a:solidFill>
+                  <a:srgbClr val="475569"/>
+                </a:solidFill>
+                <a:latin typeface="Lato"/>
+              </a:rPr>
+              <a:t> </a:t>
+            </a:r>
+            <a:r>
+              <a:rPr sz="1550" b="0" i="0" dirty="0" err="1">
+                <a:solidFill>
+                  <a:srgbClr val="475569"/>
+                </a:solidFill>
+                <a:latin typeface="Lato"/>
+              </a:rPr>
+              <a:t>ecuación</a:t>
+            </a:r>
+            <a:r>
+              <a:rPr sz="1550" b="0" i="0" dirty="0">
+                <a:solidFill>
+                  <a:srgbClr val="475569"/>
+                </a:solidFill>
+                <a:latin typeface="Lato"/>
+              </a:rPr>
+              <a:t> </a:t>
+            </a:r>
+            <a:r>
+              <a:rPr sz="1550" b="0" i="0" dirty="0" err="1">
+                <a:solidFill>
+                  <a:srgbClr val="475569"/>
+                </a:solidFill>
+                <a:latin typeface="Lato"/>
+              </a:rPr>
+              <a:t>en</a:t>
+            </a:r>
+            <a:r>
+              <a:rPr sz="1550" b="0" i="0" dirty="0">
+                <a:solidFill>
+                  <a:srgbClr val="475569"/>
+                </a:solidFill>
+                <a:latin typeface="Lato"/>
+              </a:rPr>
+              <a:t> un script </a:t>
+            </a:r>
+            <a:r>
+              <a:rPr sz="1550" b="0" i="0" dirty="0" err="1">
+                <a:solidFill>
+                  <a:srgbClr val="475569"/>
+                </a:solidFill>
+                <a:latin typeface="Lato"/>
+              </a:rPr>
+              <a:t>ejecutable</a:t>
+            </a:r>
+            <a:r>
+              <a:rPr sz="1550" b="0" i="0" dirty="0">
+                <a:solidFill>
+                  <a:srgbClr val="475569"/>
+                </a:solidFill>
+                <a:latin typeface="Lato"/>
+              </a:rPr>
+              <a:t> y </a:t>
+            </a:r>
+            <a:r>
+              <a:rPr sz="1550" b="0" i="0" dirty="0" err="1">
+                <a:solidFill>
+                  <a:srgbClr val="475569"/>
+                </a:solidFill>
+                <a:latin typeface="Lato"/>
+              </a:rPr>
+              <a:t>probado</a:t>
+            </a:r>
+            <a:r>
+              <a:rPr sz="1550" b="0" i="0" dirty="0">
+                <a:solidFill>
+                  <a:srgbClr val="475569"/>
+                </a:solidFill>
+                <a:latin typeface="Lato"/>
+              </a:rPr>
+              <a:t>.</a:t>
             </a:r>
           </a:p>
           <a:p>
@@ -25232,22 +26819,265 @@
               </a:spcAft>
             </a:pPr>
             <a:r>
-              <a:rPr sz="1550" b="1" i="0">
+              <a:rPr sz="1550" b="1" i="0" dirty="0">
                 <a:solidFill>
                   <a:srgbClr val="0EA5E9"/>
                 </a:solidFill>
                 <a:latin typeface="Lato"/>
               </a:rPr>
-              <a:t>—  Detectar patrones  </a:t>
-            </a:r>
-            <a:r>
-              <a:rPr sz="1550" b="0" i="0">
-                <a:solidFill>
-                  <a:srgbClr val="475569"/>
-                </a:solidFill>
-                <a:latin typeface="Lato"/>
-              </a:rPr>
-              <a:t>señales en los datos o vacíos en la literatura que el ojo humano podría pasar por alto.</a:t>
+              <a:t>—  </a:t>
+            </a:r>
+            <a:r>
+              <a:rPr sz="1550" b="1" i="0" dirty="0" err="1">
+                <a:solidFill>
+                  <a:srgbClr val="0EA5E9"/>
+                </a:solidFill>
+                <a:latin typeface="Lato"/>
+              </a:rPr>
+              <a:t>Detectar</a:t>
+            </a:r>
+            <a:r>
+              <a:rPr sz="1550" b="1" i="0" dirty="0">
+                <a:solidFill>
+                  <a:srgbClr val="0EA5E9"/>
+                </a:solidFill>
+                <a:latin typeface="Lato"/>
+              </a:rPr>
+              <a:t> </a:t>
+            </a:r>
+            <a:r>
+              <a:rPr sz="1550" b="1" i="0" dirty="0" err="1">
+                <a:solidFill>
+                  <a:srgbClr val="0EA5E9"/>
+                </a:solidFill>
+                <a:latin typeface="Lato"/>
+              </a:rPr>
+              <a:t>patrones</a:t>
+            </a:r>
+            <a:r>
+              <a:rPr sz="1550" b="1" i="0" dirty="0">
+                <a:solidFill>
+                  <a:srgbClr val="0EA5E9"/>
+                </a:solidFill>
+                <a:latin typeface="Lato"/>
+              </a:rPr>
+              <a:t>  </a:t>
+            </a:r>
+            <a:r>
+              <a:rPr sz="1550" b="0" i="0" dirty="0" err="1">
+                <a:solidFill>
+                  <a:srgbClr val="475569"/>
+                </a:solidFill>
+                <a:latin typeface="Lato"/>
+              </a:rPr>
+              <a:t>señales</a:t>
+            </a:r>
+            <a:r>
+              <a:rPr sz="1550" b="0" i="0" dirty="0">
+                <a:solidFill>
+                  <a:srgbClr val="475569"/>
+                </a:solidFill>
+                <a:latin typeface="Lato"/>
+              </a:rPr>
+              <a:t> </a:t>
+            </a:r>
+            <a:r>
+              <a:rPr sz="1550" b="0" i="0" dirty="0" err="1">
+                <a:solidFill>
+                  <a:srgbClr val="475569"/>
+                </a:solidFill>
+                <a:latin typeface="Lato"/>
+              </a:rPr>
+              <a:t>en</a:t>
+            </a:r>
+            <a:r>
+              <a:rPr sz="1550" b="0" i="0" dirty="0">
+                <a:solidFill>
+                  <a:srgbClr val="475569"/>
+                </a:solidFill>
+                <a:latin typeface="Lato"/>
+              </a:rPr>
+              <a:t> </a:t>
+            </a:r>
+            <a:r>
+              <a:rPr sz="1550" b="0" i="0" dirty="0" err="1">
+                <a:solidFill>
+                  <a:srgbClr val="475569"/>
+                </a:solidFill>
+                <a:latin typeface="Lato"/>
+              </a:rPr>
+              <a:t>los</a:t>
+            </a:r>
+            <a:r>
+              <a:rPr sz="1550" b="0" i="0" dirty="0">
+                <a:solidFill>
+                  <a:srgbClr val="475569"/>
+                </a:solidFill>
+                <a:latin typeface="Lato"/>
+              </a:rPr>
+              <a:t> </a:t>
+            </a:r>
+            <a:r>
+              <a:rPr sz="1550" b="0" i="0" dirty="0" err="1">
+                <a:solidFill>
+                  <a:srgbClr val="475569"/>
+                </a:solidFill>
+                <a:latin typeface="Lato"/>
+              </a:rPr>
+              <a:t>datos</a:t>
+            </a:r>
+            <a:r>
+              <a:rPr sz="1550" b="0" i="0" dirty="0">
+                <a:solidFill>
+                  <a:srgbClr val="475569"/>
+                </a:solidFill>
+                <a:latin typeface="Lato"/>
+              </a:rPr>
+              <a:t> o </a:t>
+            </a:r>
+            <a:r>
+              <a:rPr sz="1550" b="0" i="0" dirty="0" err="1">
+                <a:solidFill>
+                  <a:srgbClr val="475569"/>
+                </a:solidFill>
+                <a:latin typeface="Lato"/>
+              </a:rPr>
+              <a:t>vacíos</a:t>
+            </a:r>
+            <a:r>
+              <a:rPr sz="1550" b="0" i="0" dirty="0">
+                <a:solidFill>
+                  <a:srgbClr val="475569"/>
+                </a:solidFill>
+                <a:latin typeface="Lato"/>
+              </a:rPr>
+              <a:t> </a:t>
+            </a:r>
+            <a:r>
+              <a:rPr sz="1550" b="0" i="0" dirty="0" err="1">
+                <a:solidFill>
+                  <a:srgbClr val="475569"/>
+                </a:solidFill>
+                <a:latin typeface="Lato"/>
+              </a:rPr>
+              <a:t>en</a:t>
+            </a:r>
+            <a:r>
+              <a:rPr sz="1550" b="0" i="0" dirty="0">
+                <a:solidFill>
+                  <a:srgbClr val="475569"/>
+                </a:solidFill>
+                <a:latin typeface="Lato"/>
+              </a:rPr>
+              <a:t> la </a:t>
+            </a:r>
+            <a:r>
+              <a:rPr sz="1550" b="0" i="0" dirty="0" err="1">
+                <a:solidFill>
+                  <a:srgbClr val="475569"/>
+                </a:solidFill>
+                <a:latin typeface="Lato"/>
+              </a:rPr>
+              <a:t>literatura</a:t>
+            </a:r>
+            <a:r>
+              <a:rPr sz="1550" b="0" i="0" dirty="0">
+                <a:solidFill>
+                  <a:srgbClr val="475569"/>
+                </a:solidFill>
+                <a:latin typeface="Lato"/>
+              </a:rPr>
+              <a:t> </a:t>
+            </a:r>
+            <a:r>
+              <a:rPr sz="1550" b="0" i="0" dirty="0" err="1">
+                <a:solidFill>
+                  <a:srgbClr val="475569"/>
+                </a:solidFill>
+                <a:latin typeface="Lato"/>
+              </a:rPr>
+              <a:t>que</a:t>
+            </a:r>
+            <a:r>
+              <a:rPr sz="1550" b="0" i="0" dirty="0">
+                <a:solidFill>
+                  <a:srgbClr val="475569"/>
+                </a:solidFill>
+                <a:latin typeface="Lato"/>
+              </a:rPr>
+              <a:t> el </a:t>
+            </a:r>
+            <a:r>
+              <a:rPr sz="1550" b="0" i="0" dirty="0" err="1">
+                <a:solidFill>
+                  <a:srgbClr val="475569"/>
+                </a:solidFill>
+                <a:latin typeface="Lato"/>
+              </a:rPr>
+              <a:t>ojo</a:t>
+            </a:r>
+            <a:r>
+              <a:rPr sz="1550" b="0" i="0" dirty="0">
+                <a:solidFill>
+                  <a:srgbClr val="475569"/>
+                </a:solidFill>
+                <a:latin typeface="Lato"/>
+              </a:rPr>
+              <a:t> </a:t>
+            </a:r>
+            <a:r>
+              <a:rPr sz="1550" b="0" i="0" dirty="0" err="1">
+                <a:solidFill>
+                  <a:srgbClr val="475569"/>
+                </a:solidFill>
+                <a:latin typeface="Lato"/>
+              </a:rPr>
+              <a:t>humano</a:t>
+            </a:r>
+            <a:r>
+              <a:rPr sz="1550" b="0" i="0" dirty="0">
+                <a:solidFill>
+                  <a:srgbClr val="475569"/>
+                </a:solidFill>
+                <a:latin typeface="Lato"/>
+              </a:rPr>
+              <a:t> </a:t>
+            </a:r>
+            <a:r>
+              <a:rPr sz="1550" b="0" i="0" dirty="0" err="1">
+                <a:solidFill>
+                  <a:srgbClr val="475569"/>
+                </a:solidFill>
+                <a:latin typeface="Lato"/>
+              </a:rPr>
+              <a:t>podría</a:t>
+            </a:r>
+            <a:r>
+              <a:rPr sz="1550" b="0" i="0" dirty="0">
+                <a:solidFill>
+                  <a:srgbClr val="475569"/>
+                </a:solidFill>
+                <a:latin typeface="Lato"/>
+              </a:rPr>
+              <a:t> pasar </a:t>
+            </a:r>
+            <a:r>
+              <a:rPr sz="1550" b="0" i="0" dirty="0" err="1">
+                <a:solidFill>
+                  <a:srgbClr val="475569"/>
+                </a:solidFill>
+                <a:latin typeface="Lato"/>
+              </a:rPr>
+              <a:t>por</a:t>
+            </a:r>
+            <a:r>
+              <a:rPr sz="1550" b="0" i="0" dirty="0">
+                <a:solidFill>
+                  <a:srgbClr val="475569"/>
+                </a:solidFill>
+                <a:latin typeface="Lato"/>
+              </a:rPr>
+              <a:t> alto.</a:t>
             </a:r>
           </a:p>
           <a:p>
@@ -25260,110 +27090,157 @@
               </a:spcAft>
             </a:pPr>
             <a:r>
-              <a:rPr sz="1550" b="1" i="0">
+              <a:rPr sz="1550" b="1" i="0" dirty="0">
                 <a:solidFill>
                   <a:srgbClr val="0EA5E9"/>
                 </a:solidFill>
                 <a:latin typeface="Lato"/>
               </a:rPr>
-              <a:t>—  Documentar y comunicar  </a:t>
-            </a:r>
-            <a:r>
-              <a:rPr sz="1550" b="0" i="0">
-                <a:solidFill>
-                  <a:srgbClr val="475569"/>
-                </a:solidFill>
-                <a:latin typeface="Lato"/>
-              </a:rPr>
-              <a:t>redactar métodos, comentarios de código y borradores con rigor y trazabilidad.</a:t>
-            </a:r>
-          </a:p>
-        </p:txBody>
-      </p:sp>
-      <p:sp>
-        <p:nvSpPr>
-          <p:cNvPr id="7" name="Rounded Rectangle 6"/>
-          <p:cNvSpPr/>
-          <p:nvPr/>
-        </p:nvSpPr>
-        <p:spPr>
-          <a:xfrm>
-            <a:off x="685800" y="5806440"/>
-            <a:ext cx="10817352" cy="502920"/>
-          </a:xfrm>
-          <a:prstGeom prst="roundRect">
-            <a:avLst>
-              <a:gd name="adj" fmla="val 20000"/>
-            </a:avLst>
-          </a:prstGeom>
-          <a:solidFill>
-            <a:srgbClr val="F8FAFC"/>
-          </a:solidFill>
-          <a:ln w="12700">
-            <a:solidFill>
-              <a:srgbClr val="E2E8F0"/>
-            </a:solidFill>
-          </a:ln>
-          <a:effectLst/>
-        </p:spPr>
-        <p:style>
-          <a:lnRef idx="1">
-            <a:schemeClr val="accent1"/>
-          </a:lnRef>
-          <a:fillRef idx="3">
-            <a:schemeClr val="accent1"/>
-          </a:fillRef>
-          <a:effectRef idx="2">
-            <a:schemeClr val="accent1"/>
-          </a:effectRef>
-          <a:fontRef idx="minor">
-            <a:schemeClr val="lt1"/>
-          </a:fontRef>
-        </p:style>
-        <p:txBody>
-          <a:bodyPr rtlCol="0" anchor="ctr"/>
-          <a:lstStyle/>
-          <a:p>
-            <a:pPr algn="ctr"/>
-            <a:endParaRPr/>
-          </a:p>
-        </p:txBody>
-      </p:sp>
-      <p:sp>
-        <p:nvSpPr>
-          <p:cNvPr id="8" name="TextBox 7"/>
-          <p:cNvSpPr txBox="1"/>
-          <p:nvPr/>
-        </p:nvSpPr>
-        <p:spPr>
-          <a:xfrm>
-            <a:off x="960120" y="5806440"/>
-            <a:ext cx="10241280" cy="502920"/>
-          </a:xfrm>
-          <a:prstGeom prst="rect">
-            <a:avLst/>
-          </a:prstGeom>
-          <a:noFill/>
-        </p:spPr>
-        <p:txBody>
-          <a:bodyPr wrap="square" lIns="0" tIns="0" rIns="0" bIns="0" anchor="ctr">
-            <a:spAutoFit/>
-          </a:bodyPr>
-          <a:lstStyle/>
-          <a:p>
-            <a:pPr algn="l">
-              <a:lnSpc>
-                <a:spcPct val="100000"/>
-              </a:lnSpc>
-            </a:pPr>
-            <a:r>
-              <a:rPr sz="1150" b="0" i="1">
-                <a:solidFill>
-                  <a:srgbClr val="475569"/>
-                </a:solidFill>
-                <a:latin typeface="Lato"/>
-              </a:rPr>
-              <a:t>La responsabilidad científica —diseño, interpretación y validación— sigue siendo siempre del investigador.</a:t>
+              <a:t>—  </a:t>
+            </a:r>
+            <a:r>
+              <a:rPr sz="1550" b="1" i="0" dirty="0" err="1">
+                <a:solidFill>
+                  <a:srgbClr val="0EA5E9"/>
+                </a:solidFill>
+                <a:latin typeface="Lato"/>
+              </a:rPr>
+              <a:t>Documentar</a:t>
+            </a:r>
+            <a:r>
+              <a:rPr sz="1550" b="1" i="0" dirty="0">
+                <a:solidFill>
+                  <a:srgbClr val="0EA5E9"/>
+                </a:solidFill>
+                <a:latin typeface="Lato"/>
+              </a:rPr>
+              <a:t> y </a:t>
+            </a:r>
+            <a:r>
+              <a:rPr sz="1550" b="1" i="0" dirty="0" err="1">
+                <a:solidFill>
+                  <a:srgbClr val="0EA5E9"/>
+                </a:solidFill>
+                <a:latin typeface="Lato"/>
+              </a:rPr>
+              <a:t>comunicar</a:t>
+            </a:r>
+            <a:r>
+              <a:rPr sz="1550" b="1" i="0" dirty="0">
+                <a:solidFill>
+                  <a:srgbClr val="0EA5E9"/>
+                </a:solidFill>
+                <a:latin typeface="Lato"/>
+              </a:rPr>
+              <a:t>  </a:t>
+            </a:r>
+            <a:r>
+              <a:rPr sz="1550" b="0" i="0" dirty="0" err="1">
+                <a:solidFill>
+                  <a:srgbClr val="475569"/>
+                </a:solidFill>
+                <a:latin typeface="Lato"/>
+              </a:rPr>
+              <a:t>redactar</a:t>
+            </a:r>
+            <a:r>
+              <a:rPr sz="1550" b="0" i="0" dirty="0">
+                <a:solidFill>
+                  <a:srgbClr val="475569"/>
+                </a:solidFill>
+                <a:latin typeface="Lato"/>
+              </a:rPr>
+              <a:t> </a:t>
+            </a:r>
+            <a:r>
+              <a:rPr sz="1550" b="0" i="0" dirty="0" err="1">
+                <a:solidFill>
+                  <a:srgbClr val="475569"/>
+                </a:solidFill>
+                <a:latin typeface="Lato"/>
+              </a:rPr>
+              <a:t>métodos</a:t>
+            </a:r>
+            <a:r>
+              <a:rPr sz="1550" b="0" i="0" dirty="0">
+                <a:solidFill>
+                  <a:srgbClr val="475569"/>
+                </a:solidFill>
+                <a:latin typeface="Lato"/>
+              </a:rPr>
+              <a:t>, </a:t>
+            </a:r>
+            <a:r>
+              <a:rPr sz="1550" b="0" i="0" dirty="0" err="1">
+                <a:solidFill>
+                  <a:srgbClr val="475569"/>
+                </a:solidFill>
+                <a:latin typeface="Lato"/>
+              </a:rPr>
+              <a:t>comentarios</a:t>
+            </a:r>
+            <a:r>
+              <a:rPr sz="1550" b="0" i="0" dirty="0">
+                <a:solidFill>
+                  <a:srgbClr val="475569"/>
+                </a:solidFill>
+                <a:latin typeface="Lato"/>
+              </a:rPr>
+              <a:t> de </a:t>
+            </a:r>
+            <a:r>
+              <a:rPr sz="1550" b="0" i="0" dirty="0" err="1">
+                <a:solidFill>
+                  <a:srgbClr val="475569"/>
+                </a:solidFill>
+                <a:latin typeface="Lato"/>
+              </a:rPr>
+              <a:t>código</a:t>
+            </a:r>
+            <a:r>
+              <a:rPr sz="1550" b="0" i="0" dirty="0">
+                <a:solidFill>
+                  <a:srgbClr val="475569"/>
+                </a:solidFill>
+                <a:latin typeface="Lato"/>
+              </a:rPr>
+              <a:t> y </a:t>
+            </a:r>
+            <a:r>
+              <a:rPr sz="1550" b="0" i="0" dirty="0" err="1">
+                <a:solidFill>
+                  <a:srgbClr val="475569"/>
+                </a:solidFill>
+                <a:latin typeface="Lato"/>
+              </a:rPr>
+              <a:t>borradores</a:t>
+            </a:r>
+            <a:r>
+              <a:rPr sz="1550" b="0" i="0" dirty="0">
+                <a:solidFill>
+                  <a:srgbClr val="475569"/>
+                </a:solidFill>
+                <a:latin typeface="Lato"/>
+              </a:rPr>
+              <a:t> con rigor y </a:t>
+            </a:r>
+            <a:r>
+              <a:rPr sz="1550" b="0" i="0" dirty="0" err="1">
+                <a:solidFill>
+                  <a:srgbClr val="475569"/>
+                </a:solidFill>
+                <a:latin typeface="Lato"/>
+              </a:rPr>
+              <a:t>trazabilidad</a:t>
+            </a:r>
+            <a:r>
+              <a:rPr sz="1550" b="0" i="0" dirty="0">
+                <a:solidFill>
+                  <a:srgbClr val="475569"/>
+                </a:solidFill>
+                <a:latin typeface="Lato"/>
+              </a:rPr>
+              <a:t>.</a:t>
             </a:r>
           </a:p>
         </p:txBody>
@@ -25806,6 +27683,36 @@
           </a:p>
         </p:txBody>
       </p:sp>
+      <p:pic>
+        <p:nvPicPr>
+          <p:cNvPr id="9" name="Imagen 8">
+            <a:extLst>
+              <a:ext uri="{FF2B5EF4-FFF2-40B4-BE49-F238E27FC236}">
+                <a16:creationId xmlns:a16="http://schemas.microsoft.com/office/drawing/2014/main" id="{378DF1BE-F375-2007-3128-F8A5E976575E}"/>
+              </a:ext>
+            </a:extLst>
+          </p:cNvPr>
+          <p:cNvPicPr>
+            <a:picLocks noChangeAspect="1"/>
+          </p:cNvPicPr>
+          <p:nvPr/>
+        </p:nvPicPr>
+        <p:blipFill>
+          <a:blip r:embed="rId2"/>
+          <a:stretch>
+            <a:fillRect/>
+          </a:stretch>
+        </p:blipFill>
+        <p:spPr>
+          <a:xfrm>
+            <a:off x="465406" y="4745690"/>
+            <a:ext cx="10827434" cy="530398"/>
+          </a:xfrm>
+          <a:prstGeom prst="rect">
+            <a:avLst/>
+          </a:prstGeom>
+        </p:spPr>
+      </p:pic>
     </p:spTree>
   </p:cSld>
   <p:clrMapOvr>
@@ -28467,7 +30374,7 @@
         <p:spPr>
           <a:xfrm>
             <a:off x="914400" y="4709160"/>
-            <a:ext cx="8961120" cy="640080"/>
+            <a:ext cx="8961120" cy="230832"/>
           </a:xfrm>
           <a:prstGeom prst="rect">
             <a:avLst/>
@@ -28486,13 +30393,175 @@
               </a:lnSpc>
             </a:pPr>
             <a:r>
-              <a:rPr sz="1500" b="0" i="0">
+              <a:rPr lang="es-CO" sz="1500" b="0" i="0" dirty="0">
                 <a:solidFill>
                   <a:srgbClr val="E2E8F0"/>
                 </a:solidFill>
                 <a:latin typeface="Lato"/>
               </a:rPr>
-              <a:t>Cómo construir un estado del arte sólido en minutos, sin sacrificar el rigor.</a:t>
+              <a:t>¿</a:t>
+            </a:r>
+            <a:r>
+              <a:rPr sz="1500" b="0" i="0" dirty="0" err="1">
+                <a:solidFill>
+                  <a:srgbClr val="E2E8F0"/>
+                </a:solidFill>
+                <a:latin typeface="Lato"/>
+              </a:rPr>
+              <a:t>Cómo</a:t>
+            </a:r>
+            <a:r>
+              <a:rPr sz="1500" b="0" i="0" dirty="0">
+                <a:solidFill>
+                  <a:srgbClr val="E2E8F0"/>
+                </a:solidFill>
+                <a:latin typeface="Lato"/>
+              </a:rPr>
+              <a:t> </a:t>
+            </a:r>
+            <a:r>
+              <a:rPr sz="1500" b="0" i="0" dirty="0" err="1">
+                <a:solidFill>
+                  <a:srgbClr val="E2E8F0"/>
+                </a:solidFill>
+                <a:latin typeface="Lato"/>
+              </a:rPr>
+              <a:t>construir</a:t>
+            </a:r>
+            <a:r>
+              <a:rPr sz="1500" b="0" i="0" dirty="0">
+                <a:solidFill>
+                  <a:srgbClr val="E2E8F0"/>
+                </a:solidFill>
+                <a:latin typeface="Lato"/>
+              </a:rPr>
+              <a:t> un </a:t>
+            </a:r>
+            <a:r>
+              <a:rPr sz="1500" b="0" i="0" dirty="0" err="1">
+                <a:solidFill>
+                  <a:srgbClr val="E2E8F0"/>
+                </a:solidFill>
+                <a:latin typeface="Lato"/>
+              </a:rPr>
+              <a:t>estado</a:t>
+            </a:r>
+            <a:r>
+              <a:rPr sz="1500" b="0" i="0" dirty="0">
+                <a:solidFill>
+                  <a:srgbClr val="E2E8F0"/>
+                </a:solidFill>
+                <a:latin typeface="Lato"/>
+              </a:rPr>
+              <a:t> del </a:t>
+            </a:r>
+            <a:r>
+              <a:rPr sz="1500" b="0" i="0" dirty="0" err="1">
+                <a:solidFill>
+                  <a:srgbClr val="E2E8F0"/>
+                </a:solidFill>
+                <a:latin typeface="Lato"/>
+              </a:rPr>
+              <a:t>arte</a:t>
+            </a:r>
+            <a:r>
+              <a:rPr sz="1500" b="0" i="0" dirty="0">
+                <a:solidFill>
+                  <a:srgbClr val="E2E8F0"/>
+                </a:solidFill>
+                <a:latin typeface="Lato"/>
+              </a:rPr>
+              <a:t> </a:t>
+            </a:r>
+            <a:r>
+              <a:rPr sz="1500" b="0" i="0" dirty="0" err="1">
+                <a:solidFill>
+                  <a:srgbClr val="E2E8F0"/>
+                </a:solidFill>
+                <a:latin typeface="Lato"/>
+              </a:rPr>
+              <a:t>sólido</a:t>
+            </a:r>
+            <a:r>
+              <a:rPr sz="1500" b="0" i="0" dirty="0">
+                <a:solidFill>
+                  <a:srgbClr val="E2E8F0"/>
+                </a:solidFill>
+                <a:latin typeface="Lato"/>
+              </a:rPr>
+              <a:t> </a:t>
+            </a:r>
+            <a:r>
+              <a:rPr sz="1500" b="0" i="0" dirty="0" err="1">
+                <a:solidFill>
+                  <a:srgbClr val="E2E8F0"/>
+                </a:solidFill>
+                <a:latin typeface="Lato"/>
+              </a:rPr>
+              <a:t>en</a:t>
+            </a:r>
+            <a:r>
+              <a:rPr sz="1500" b="0" i="0" dirty="0">
+                <a:solidFill>
+                  <a:srgbClr val="E2E8F0"/>
+                </a:solidFill>
+                <a:latin typeface="Lato"/>
+              </a:rPr>
+              <a:t> </a:t>
+            </a:r>
+            <a:r>
+              <a:rPr sz="1500" b="0" i="0" dirty="0" err="1">
+                <a:solidFill>
+                  <a:srgbClr val="E2E8F0"/>
+                </a:solidFill>
+                <a:latin typeface="Lato"/>
+              </a:rPr>
+              <a:t>minutos</a:t>
+            </a:r>
+            <a:r>
+              <a:rPr sz="1500" b="0" i="0" dirty="0">
+                <a:solidFill>
+                  <a:srgbClr val="E2E8F0"/>
+                </a:solidFill>
+                <a:latin typeface="Lato"/>
+              </a:rPr>
+              <a:t>, sin </a:t>
+            </a:r>
+            <a:r>
+              <a:rPr sz="1500" b="0" i="0" dirty="0" err="1">
+                <a:solidFill>
+                  <a:srgbClr val="E2E8F0"/>
+                </a:solidFill>
+                <a:latin typeface="Lato"/>
+              </a:rPr>
+              <a:t>sacrificar</a:t>
+            </a:r>
+            <a:r>
+              <a:rPr sz="1500" b="0" i="0" dirty="0">
+                <a:solidFill>
+                  <a:srgbClr val="E2E8F0"/>
+                </a:solidFill>
+                <a:latin typeface="Lato"/>
+              </a:rPr>
+              <a:t> el rigor</a:t>
+            </a:r>
+            <a:r>
+              <a:rPr lang="es-CO" sz="1500" b="0" i="0" dirty="0">
+                <a:solidFill>
+                  <a:srgbClr val="E2E8F0"/>
+                </a:solidFill>
+                <a:latin typeface="Lato"/>
+              </a:rPr>
+              <a:t>?</a:t>
+            </a:r>
+            <a:r>
+              <a:rPr sz="1500" b="0" i="0" dirty="0">
+                <a:solidFill>
+                  <a:srgbClr val="E2E8F0"/>
+                </a:solidFill>
+                <a:latin typeface="Lato"/>
+              </a:rPr>
+              <a:t>.</a:t>
             </a:r>
           </a:p>
         </p:txBody>

</xml_diff>

<commit_message>
chore: ignore temporary documentation file in references directory
</commit_message>
<xml_diff>
--- a/Investigacion_Aumentada_IA_para_la_Ciencia.pptx
+++ b/Investigacion_Aumentada_IA_para_la_Ciencia.pptx
@@ -339,7 +339,7 @@
           <a:p>
             <a:fld id="{5BCAD085-E8A6-8845-BD4E-CB4CCA059FC4}" type="datetimeFigureOut">
               <a:rPr lang="en-US" smtClean="0"/>
-              <a:t>8/26/2026</a:t>
+              <a:t>8/27/2026</a:t>
             </a:fld>
             <a:endParaRPr lang="en-US"/>
           </a:p>
@@ -507,7 +507,7 @@
           <a:p>
             <a:fld id="{5BCAD085-E8A6-8845-BD4E-CB4CCA059FC4}" type="datetimeFigureOut">
               <a:rPr lang="en-US" smtClean="0"/>
-              <a:t>8/26/2026</a:t>
+              <a:t>8/27/2026</a:t>
             </a:fld>
             <a:endParaRPr lang="en-US"/>
           </a:p>
@@ -685,7 +685,7 @@
           <a:p>
             <a:fld id="{5BCAD085-E8A6-8845-BD4E-CB4CCA059FC4}" type="datetimeFigureOut">
               <a:rPr lang="en-US" smtClean="0"/>
-              <a:t>8/26/2026</a:t>
+              <a:t>8/27/2026</a:t>
             </a:fld>
             <a:endParaRPr lang="en-US"/>
           </a:p>
@@ -853,7 +853,7 @@
           <a:p>
             <a:fld id="{5BCAD085-E8A6-8845-BD4E-CB4CCA059FC4}" type="datetimeFigureOut">
               <a:rPr lang="en-US" smtClean="0"/>
-              <a:t>8/26/2026</a:t>
+              <a:t>8/27/2026</a:t>
             </a:fld>
             <a:endParaRPr lang="en-US"/>
           </a:p>
@@ -1098,7 +1098,7 @@
           <a:p>
             <a:fld id="{5BCAD085-E8A6-8845-BD4E-CB4CCA059FC4}" type="datetimeFigureOut">
               <a:rPr lang="en-US" smtClean="0"/>
-              <a:t>8/26/2026</a:t>
+              <a:t>8/27/2026</a:t>
             </a:fld>
             <a:endParaRPr lang="en-US"/>
           </a:p>
@@ -1383,7 +1383,7 @@
           <a:p>
             <a:fld id="{5BCAD085-E8A6-8845-BD4E-CB4CCA059FC4}" type="datetimeFigureOut">
               <a:rPr lang="en-US" smtClean="0"/>
-              <a:t>8/26/2026</a:t>
+              <a:t>8/27/2026</a:t>
             </a:fld>
             <a:endParaRPr lang="en-US"/>
           </a:p>
@@ -1802,7 +1802,7 @@
           <a:p>
             <a:fld id="{5BCAD085-E8A6-8845-BD4E-CB4CCA059FC4}" type="datetimeFigureOut">
               <a:rPr lang="en-US" smtClean="0"/>
-              <a:t>8/26/2026</a:t>
+              <a:t>8/27/2026</a:t>
             </a:fld>
             <a:endParaRPr lang="en-US"/>
           </a:p>
@@ -1919,7 +1919,7 @@
           <a:p>
             <a:fld id="{5BCAD085-E8A6-8845-BD4E-CB4CCA059FC4}" type="datetimeFigureOut">
               <a:rPr lang="en-US" smtClean="0"/>
-              <a:t>8/26/2026</a:t>
+              <a:t>8/27/2026</a:t>
             </a:fld>
             <a:endParaRPr lang="en-US"/>
           </a:p>
@@ -2014,7 +2014,7 @@
           <a:p>
             <a:fld id="{5BCAD085-E8A6-8845-BD4E-CB4CCA059FC4}" type="datetimeFigureOut">
               <a:rPr lang="en-US" smtClean="0"/>
-              <a:t>8/26/2026</a:t>
+              <a:t>8/27/2026</a:t>
             </a:fld>
             <a:endParaRPr lang="en-US"/>
           </a:p>
@@ -2289,7 +2289,7 @@
           <a:p>
             <a:fld id="{5BCAD085-E8A6-8845-BD4E-CB4CCA059FC4}" type="datetimeFigureOut">
               <a:rPr lang="en-US" smtClean="0"/>
-              <a:t>8/26/2026</a:t>
+              <a:t>8/27/2026</a:t>
             </a:fld>
             <a:endParaRPr lang="en-US"/>
           </a:p>
@@ -2541,7 +2541,7 @@
           <a:p>
             <a:fld id="{5BCAD085-E8A6-8845-BD4E-CB4CCA059FC4}" type="datetimeFigureOut">
               <a:rPr lang="en-US" smtClean="0"/>
-              <a:t>8/26/2026</a:t>
+              <a:t>8/27/2026</a:t>
             </a:fld>
             <a:endParaRPr lang="en-US"/>
           </a:p>
@@ -2752,7 +2752,7 @@
           <a:p>
             <a:fld id="{5BCAD085-E8A6-8845-BD4E-CB4CCA059FC4}" type="datetimeFigureOut">
               <a:rPr lang="en-US" smtClean="0"/>
-              <a:t>8/26/2026</a:t>
+              <a:t>8/27/2026</a:t>
             </a:fld>
             <a:endParaRPr lang="en-US"/>
           </a:p>
@@ -26318,7 +26318,7 @@
             <a:r>
               <a:rPr sz="1450" b="0" i="1" dirty="0" err="1">
                 <a:solidFill>
-                  <a:srgbClr val="475569"/>
+                  <a:srgbClr val="FF0000"/>
                 </a:solidFill>
                 <a:latin typeface="Lato"/>
               </a:rPr>
@@ -26327,7 +26327,7 @@
             <a:r>
               <a:rPr sz="1450" b="0" i="1" dirty="0">
                 <a:solidFill>
-                  <a:srgbClr val="475569"/>
+                  <a:srgbClr val="FF0000"/>
                 </a:solidFill>
                 <a:latin typeface="Lato"/>
               </a:rPr>
@@ -26336,7 +26336,7 @@
             <a:r>
               <a:rPr sz="1450" b="0" i="1" dirty="0" err="1">
                 <a:solidFill>
-                  <a:srgbClr val="475569"/>
+                  <a:srgbClr val="FF0000"/>
                 </a:solidFill>
                 <a:latin typeface="Lato"/>
               </a:rPr>
@@ -26345,11 +26345,20 @@
             <a:r>
               <a:rPr sz="1450" b="0" i="1" dirty="0">
                 <a:solidFill>
-                  <a:srgbClr val="475569"/>
-                </a:solidFill>
-                <a:latin typeface="Lato"/>
-              </a:rPr>
-              <a:t> la </a:t>
+                  <a:srgbClr val="FF0000"/>
+                </a:solidFill>
+                <a:latin typeface="Lato"/>
+              </a:rPr>
+              <a:t> </a:t>
+            </a:r>
+            <a:r>
+              <a:rPr sz="1450" b="0" i="1" dirty="0">
+                <a:solidFill>
+                  <a:srgbClr val="475569"/>
+                </a:solidFill>
+                <a:latin typeface="Lato"/>
+              </a:rPr>
+              <a:t>la </a:t>
             </a:r>
             <a:r>
               <a:rPr sz="1450" b="0" i="1" dirty="0" err="1">

</xml_diff>